<commit_message>
Añade subsección Airbnb (casas/aptos enteros) con datos reales + dimensión de baños
- Scrapers nuevos: explora_airbnb.py (listados, alojamiento entero, zonas seguras)
  y explora_fichas_airbnb.py (capacidad, habitaciones, camas y baños por ficha).
  Barrido real con Playwright en el devcontainer, fechas 30 oct-2 nov, 7 personas.
- Dimensión de baños como informativa (columna '¿Baño compartido?'), sin tocar
  pesos ni filtros: el puntaje y el ranking de hostales quedan intactos.
- Subsección Airbnb en los 4 entregables (informe, Excel, PDF, presentación) con
  las mejores casas/aptos enteros y dos contraejemplos (por qué se miran baños y camas).
- Hallazgo: casa entera real desde ~$77k-90k pp/3n (muy por debajo del estimado
  viejo de $300k); la lectura 'Casa entera' pasa a $278.571 pp (DENTRO) con el precio real.
- Documenta D-005 en la bitácora y AIRBNB_ENTEROS en el diccionario de datos.
</commit_message>
<xml_diff>
--- a/output/Mini-Boom-en-Cali_Presentacion.pptx
+++ b/output/Mini-Boom-en-Cali_Presentacion.pptx
@@ -16,6 +16,7 @@
     <p:sldId id="264" r:id="rId15"/>
     <p:sldId id="265" r:id="rId16"/>
     <p:sldId id="266" r:id="rId17"/>
+    <p:sldId id="267" r:id="rId18"/>
   </p:sldIdLst>
   <p:sldSz cx="12191695" cy="6858000" type="screen4x3"/>
   <p:notesSz cx="6858000" cy="9144000"/>
@@ -3726,6 +3727,1130 @@
       <p:grpSpPr/>
       <p:sp>
         <p:nvSpPr>
+          <p:cNvPr id="2" name="Rounded Rectangle 1"/>
+          <p:cNvSpPr/>
+          <p:nvPr/>
+        </p:nvSpPr>
+        <p:spPr>
+          <a:xfrm>
+            <a:off x="365760" y="274320"/>
+            <a:ext cx="11457432" cy="749808"/>
+          </a:xfrm>
+          <a:prstGeom prst="roundRect">
+            <a:avLst>
+              <a:gd name="adj" fmla="val 50000"/>
+            </a:avLst>
+          </a:prstGeom>
+          <a:solidFill>
+            <a:srgbClr val="B5765C"/>
+          </a:solidFill>
+          <a:ln>
+            <a:noFill/>
+          </a:ln>
+          <a:effectLst>
+            <a:outerShdw blurRad="95000" dist="40000" dir="5400000" rotWithShape="0">
+              <a:srgbClr val="6E5B4E">
+                <a:alpha val="32000"/>
+              </a:srgbClr>
+            </a:outerShdw>
+          </a:effectLst>
+        </p:spPr>
+        <p:style>
+          <a:lnRef idx="1">
+            <a:schemeClr val="accent1"/>
+          </a:lnRef>
+          <a:fillRef idx="3">
+            <a:schemeClr val="accent1"/>
+          </a:fillRef>
+          <a:effectRef idx="2">
+            <a:schemeClr val="accent1"/>
+          </a:effectRef>
+          <a:fontRef idx="minor">
+            <a:schemeClr val="lt1"/>
+          </a:fontRef>
+        </p:style>
+        <p:txBody>
+          <a:bodyPr rtlCol="0" anchor="ctr"/>
+          <a:lstStyle/>
+          <a:p>
+            <a:pPr algn="ctr"/>
+          </a:p>
+        </p:txBody>
+      </p:sp>
+      <p:sp>
+        <p:nvSpPr>
+          <p:cNvPr id="3" name="TextBox 2"/>
+          <p:cNvSpPr txBox="1"/>
+          <p:nvPr/>
+        </p:nvSpPr>
+        <p:spPr>
+          <a:xfrm>
+            <a:off x="777240" y="274320"/>
+            <a:ext cx="10789920" cy="749808"/>
+          </a:xfrm>
+          <a:prstGeom prst="rect">
+            <a:avLst/>
+          </a:prstGeom>
+          <a:noFill/>
+        </p:spPr>
+        <p:txBody>
+          <a:bodyPr wrap="square" anchor="ctr">
+            <a:spAutoFit/>
+          </a:bodyPr>
+          <a:lstStyle/>
+          <a:p>
+            <a:pPr algn="l"/>
+            <a:r>
+              <a:rPr sz="2400" b="1">
+                <a:solidFill>
+                  <a:srgbClr val="FFFFFF"/>
+                </a:solidFill>
+              </a:rPr>
+              <a:t>🚙   Opciones de vehículo (7 puestos)</a:t>
+            </a:r>
+          </a:p>
+        </p:txBody>
+      </p:sp>
+      <p:sp>
+        <p:nvSpPr>
+          <p:cNvPr id="4" name="TextBox 3"/>
+          <p:cNvSpPr txBox="1"/>
+          <p:nvPr/>
+        </p:nvSpPr>
+        <p:spPr>
+          <a:xfrm>
+            <a:off x="548640" y="1097280"/>
+            <a:ext cx="11064240" cy="502920"/>
+          </a:xfrm>
+          <a:prstGeom prst="rect">
+            <a:avLst/>
+          </a:prstGeom>
+          <a:noFill/>
+        </p:spPr>
+        <p:txBody>
+          <a:bodyPr wrap="square" anchor="t">
+            <a:spAutoFit/>
+          </a:bodyPr>
+          <a:lstStyle/>
+          <a:p>
+            <a:pPr algn="l"/>
+            <a:r>
+              <a:rPr sz="1300" b="0">
+                <a:solidFill>
+                  <a:srgbClr val="463A32"/>
+                </a:solidFill>
+              </a:rPr>
+              <a:t>Lo que cambia según dónde se recoja: local (entrega, cuadra con la llegada) vs mostrador (más barato, horario rígido).</a:t>
+            </a:r>
+          </a:p>
+        </p:txBody>
+      </p:sp>
+      <p:graphicFrame>
+        <p:nvGraphicFramePr>
+          <p:cNvPr id="5" name="Table 4"/>
+          <p:cNvGraphicFramePr>
+            <a:graphicFrameLocks noGrp="1"/>
+          </p:cNvGraphicFramePr>
+          <p:nvPr/>
+        </p:nvGraphicFramePr>
+        <p:xfrm>
+          <a:off x="365760" y="1691640"/>
+          <a:ext cx="11430000" cy="3657600"/>
+        </p:xfrm>
+        <a:graphic>
+          <a:graphicData uri="http://schemas.openxmlformats.org/drawingml/2006/table">
+            <a:tbl>
+              <a:tblPr firstRow="1" bandRow="1">
+                <a:tableStyleId>{5C22544A-7EE6-4342-B048-85BDC9FD1C3A}</a:tableStyleId>
+              </a:tblPr>
+              <a:tblGrid>
+                <a:gridCol w="2468880"/>
+                <a:gridCol w="1965960"/>
+                <a:gridCol w="1828800"/>
+                <a:gridCol w="1600200"/>
+                <a:gridCol w="2834640"/>
+                <a:gridCol w="731520"/>
+              </a:tblGrid>
+              <a:tr h="522514">
+                <a:tc>
+                  <a:txBody>
+                    <a:bodyPr/>
+                    <a:lstStyle/>
+                    <a:p>
+                      <a:r>
+                        <a:rPr b="1" sz="1100">
+                          <a:solidFill>
+                            <a:srgbClr val="FFFFFF"/>
+                          </a:solidFill>
+                        </a:rPr>
+                        <a:t>Vehículo (7 puestos)</a:t>
+                      </a:r>
+                    </a:p>
+                  </a:txBody>
+                  <a:tcPr>
+                    <a:solidFill>
+                      <a:srgbClr val="B5765C"/>
+                    </a:solidFill>
+                  </a:tcPr>
+                </a:tc>
+                <a:tc>
+                  <a:txBody>
+                    <a:bodyPr/>
+                    <a:lstStyle/>
+                    <a:p>
+                      <a:r>
+                        <a:rPr b="1" sz="1100">
+                          <a:solidFill>
+                            <a:srgbClr val="FFFFFF"/>
+                          </a:solidFill>
+                        </a:rPr>
+                        <a:t>Agencia</a:t>
+                      </a:r>
+                    </a:p>
+                  </a:txBody>
+                  <a:tcPr>
+                    <a:solidFill>
+                      <a:srgbClr val="B5765C"/>
+                    </a:solidFill>
+                  </a:tcPr>
+                </a:tc>
+                <a:tc>
+                  <a:txBody>
+                    <a:bodyPr/>
+                    <a:lstStyle/>
+                    <a:p>
+                      <a:r>
+                        <a:rPr b="1" sz="1100">
+                          <a:solidFill>
+                            <a:srgbClr val="FFFFFF"/>
+                          </a:solidFill>
+                        </a:rPr>
+                        <a:t>Tarifa (3 días)</a:t>
+                      </a:r>
+                    </a:p>
+                  </a:txBody>
+                  <a:tcPr>
+                    <a:solidFill>
+                      <a:srgbClr val="B5765C"/>
+                    </a:solidFill>
+                  </a:tcPr>
+                </a:tc>
+                <a:tc>
+                  <a:txBody>
+                    <a:bodyPr/>
+                    <a:lstStyle/>
+                    <a:p>
+                      <a:r>
+                        <a:rPr b="1" sz="1100">
+                          <a:solidFill>
+                            <a:srgbClr val="FFFFFF"/>
+                          </a:solidFill>
+                        </a:rPr>
+                        <a:t>Por persona</a:t>
+                      </a:r>
+                    </a:p>
+                  </a:txBody>
+                  <a:tcPr>
+                    <a:solidFill>
+                      <a:srgbClr val="B5765C"/>
+                    </a:solidFill>
+                  </a:tcPr>
+                </a:tc>
+                <a:tc>
+                  <a:txBody>
+                    <a:bodyPr/>
+                    <a:lstStyle/>
+                    <a:p>
+                      <a:r>
+                        <a:rPr b="1" sz="1100">
+                          <a:solidFill>
+                            <a:srgbClr val="FFFFFF"/>
+                          </a:solidFill>
+                        </a:rPr>
+                        <a:t>¿Cuadra con la llegada?</a:t>
+                      </a:r>
+                    </a:p>
+                  </a:txBody>
+                  <a:tcPr>
+                    <a:solidFill>
+                      <a:srgbClr val="B5765C"/>
+                    </a:solidFill>
+                  </a:tcPr>
+                </a:tc>
+                <a:tc>
+                  <a:txBody>
+                    <a:bodyPr/>
+                    <a:lstStyle/>
+                    <a:p>
+                      <a:r>
+                        <a:rPr b="1" sz="1100">
+                          <a:solidFill>
+                            <a:srgbClr val="FFFFFF"/>
+                          </a:solidFill>
+                        </a:rPr>
+                        <a:t>Ver</a:t>
+                      </a:r>
+                    </a:p>
+                  </a:txBody>
+                  <a:tcPr>
+                    <a:solidFill>
+                      <a:srgbClr val="B5765C"/>
+                    </a:solidFill>
+                  </a:tcPr>
+                </a:tc>
+              </a:tr>
+              <a:tr h="522514">
+                <a:tc>
+                  <a:txBody>
+                    <a:bodyPr/>
+                    <a:lstStyle/>
+                    <a:p>
+                      <a:r>
+                        <a:rPr sz="1050">
+                          <a:solidFill>
+                            <a:srgbClr val="463A32"/>
+                          </a:solidFill>
+                        </a:rPr>
+                        <a:t>Chevrolet Captiva Turbo</a:t>
+                      </a:r>
+                    </a:p>
+                  </a:txBody>
+                  <a:tcPr>
+                    <a:solidFill>
+                      <a:srgbClr val="F0E0C6"/>
+                    </a:solidFill>
+                  </a:tcPr>
+                </a:tc>
+                <a:tc>
+                  <a:txBody>
+                    <a:bodyPr/>
+                    <a:lstStyle/>
+                    <a:p>
+                      <a:r>
+                        <a:rPr sz="1050">
+                          <a:solidFill>
+                            <a:srgbClr val="463A32"/>
+                          </a:solidFill>
+                        </a:rPr>
+                        <a:t>Farallones (local)</a:t>
+                      </a:r>
+                    </a:p>
+                  </a:txBody>
+                  <a:tcPr>
+                    <a:solidFill>
+                      <a:srgbClr val="F0E0C6"/>
+                    </a:solidFill>
+                  </a:tcPr>
+                </a:tc>
+                <a:tc>
+                  <a:txBody>
+                    <a:bodyPr/>
+                    <a:lstStyle/>
+                    <a:p>
+                      <a:r>
+                        <a:rPr sz="1050">
+                          <a:solidFill>
+                            <a:srgbClr val="463A32"/>
+                          </a:solidFill>
+                        </a:rPr>
+                        <a:t>~$1.200.000</a:t>
+                      </a:r>
+                    </a:p>
+                  </a:txBody>
+                  <a:tcPr>
+                    <a:solidFill>
+                      <a:srgbClr val="F0E0C6"/>
+                    </a:solidFill>
+                  </a:tcPr>
+                </a:tc>
+                <a:tc>
+                  <a:txBody>
+                    <a:bodyPr/>
+                    <a:lstStyle/>
+                    <a:p>
+                      <a:pPr algn="ctr"/>
+                      <a:r>
+                        <a:rPr sz="1050">
+                          <a:solidFill>
+                            <a:srgbClr val="463A32"/>
+                          </a:solidFill>
+                        </a:rPr>
+                        <a:t>$171.429</a:t>
+                      </a:r>
+                    </a:p>
+                  </a:txBody>
+                  <a:tcPr>
+                    <a:solidFill>
+                      <a:srgbClr val="F0E0C6"/>
+                    </a:solidFill>
+                  </a:tcPr>
+                </a:tc>
+                <a:tc>
+                  <a:txBody>
+                    <a:bodyPr/>
+                    <a:lstStyle/>
+                    <a:p>
+                      <a:r>
+                        <a:rPr sz="1050">
+                          <a:solidFill>
+                            <a:srgbClr val="463A32"/>
+                          </a:solidFill>
+                        </a:rPr>
+                        <a:t>Sí — oficina en el aeropuerto y domicilio</a:t>
+                      </a:r>
+                    </a:p>
+                  </a:txBody>
+                  <a:tcPr>
+                    <a:solidFill>
+                      <a:srgbClr val="F0E0C6"/>
+                    </a:solidFill>
+                  </a:tcPr>
+                </a:tc>
+                <a:tc>
+                  <a:txBody>
+                    <a:bodyPr/>
+                    <a:lstStyle/>
+                    <a:p>
+                      <a:pPr algn="ctr"/>
+                      <a:r>
+                        <a:rPr sz="1050" u="sng">
+                          <a:solidFill>
+                            <a:srgbClr val="8F5A44"/>
+                          </a:solidFill>
+                          <a:hlinkClick r:id="rId2"/>
+                        </a:rPr>
+                        <a:t>ver</a:t>
+                      </a:r>
+                    </a:p>
+                  </a:txBody>
+                  <a:tcPr>
+                    <a:solidFill>
+                      <a:srgbClr val="F0E0C6"/>
+                    </a:solidFill>
+                  </a:tcPr>
+                </a:tc>
+              </a:tr>
+              <a:tr h="522514">
+                <a:tc>
+                  <a:txBody>
+                    <a:bodyPr/>
+                    <a:lstStyle/>
+                    <a:p>
+                      <a:r>
+                        <a:rPr sz="1050">
+                          <a:solidFill>
+                            <a:srgbClr val="463A32"/>
+                          </a:solidFill>
+                        </a:rPr>
+                        <a:t>Toyota Fortuner</a:t>
+                      </a:r>
+                    </a:p>
+                  </a:txBody>
+                  <a:tcPr>
+                    <a:solidFill>
+                      <a:srgbClr val="F0E0C6"/>
+                    </a:solidFill>
+                  </a:tcPr>
+                </a:tc>
+                <a:tc>
+                  <a:txBody>
+                    <a:bodyPr/>
+                    <a:lstStyle/>
+                    <a:p>
+                      <a:r>
+                        <a:rPr sz="1050">
+                          <a:solidFill>
+                            <a:srgbClr val="463A32"/>
+                          </a:solidFill>
+                        </a:rPr>
+                        <a:t>Farallones (local)</a:t>
+                      </a:r>
+                    </a:p>
+                  </a:txBody>
+                  <a:tcPr>
+                    <a:solidFill>
+                      <a:srgbClr val="F0E0C6"/>
+                    </a:solidFill>
+                  </a:tcPr>
+                </a:tc>
+                <a:tc>
+                  <a:txBody>
+                    <a:bodyPr/>
+                    <a:lstStyle/>
+                    <a:p>
+                      <a:r>
+                        <a:rPr sz="1050">
+                          <a:solidFill>
+                            <a:srgbClr val="463A32"/>
+                          </a:solidFill>
+                        </a:rPr>
+                        <a:t>desde $1.140.000</a:t>
+                      </a:r>
+                    </a:p>
+                  </a:txBody>
+                  <a:tcPr>
+                    <a:solidFill>
+                      <a:srgbClr val="F0E0C6"/>
+                    </a:solidFill>
+                  </a:tcPr>
+                </a:tc>
+                <a:tc>
+                  <a:txBody>
+                    <a:bodyPr/>
+                    <a:lstStyle/>
+                    <a:p>
+                      <a:pPr algn="ctr"/>
+                      <a:r>
+                        <a:rPr sz="1050">
+                          <a:solidFill>
+                            <a:srgbClr val="463A32"/>
+                          </a:solidFill>
+                        </a:rPr>
+                        <a:t>$162.857</a:t>
+                      </a:r>
+                    </a:p>
+                  </a:txBody>
+                  <a:tcPr>
+                    <a:solidFill>
+                      <a:srgbClr val="F0E0C6"/>
+                    </a:solidFill>
+                  </a:tcPr>
+                </a:tc>
+                <a:tc>
+                  <a:txBody>
+                    <a:bodyPr/>
+                    <a:lstStyle/>
+                    <a:p>
+                      <a:r>
+                        <a:rPr sz="1050">
+                          <a:solidFill>
+                            <a:srgbClr val="463A32"/>
+                          </a:solidFill>
+                        </a:rPr>
+                        <a:t>Sí — entrega coordinando el vuelo</a:t>
+                      </a:r>
+                    </a:p>
+                  </a:txBody>
+                  <a:tcPr>
+                    <a:solidFill>
+                      <a:srgbClr val="F0E0C6"/>
+                    </a:solidFill>
+                  </a:tcPr>
+                </a:tc>
+                <a:tc>
+                  <a:txBody>
+                    <a:bodyPr/>
+                    <a:lstStyle/>
+                    <a:p>
+                      <a:pPr algn="ctr"/>
+                      <a:r>
+                        <a:rPr sz="1050" u="sng">
+                          <a:solidFill>
+                            <a:srgbClr val="8F5A44"/>
+                          </a:solidFill>
+                          <a:hlinkClick r:id="rId3"/>
+                        </a:rPr>
+                        <a:t>ver</a:t>
+                      </a:r>
+                    </a:p>
+                  </a:txBody>
+                  <a:tcPr>
+                    <a:solidFill>
+                      <a:srgbClr val="F0E0C6"/>
+                    </a:solidFill>
+                  </a:tcPr>
+                </a:tc>
+              </a:tr>
+              <a:tr h="522514">
+                <a:tc>
+                  <a:txBody>
+                    <a:bodyPr/>
+                    <a:lstStyle/>
+                    <a:p>
+                      <a:r>
+                        <a:rPr sz="1050">
+                          <a:solidFill>
+                            <a:srgbClr val="463A32"/>
+                          </a:solidFill>
+                        </a:rPr>
+                        <a:t>Mitsubishi Montero Sport</a:t>
+                      </a:r>
+                    </a:p>
+                  </a:txBody>
+                  <a:tcPr>
+                    <a:solidFill>
+                      <a:srgbClr val="F0E0C6"/>
+                    </a:solidFill>
+                  </a:tcPr>
+                </a:tc>
+                <a:tc>
+                  <a:txBody>
+                    <a:bodyPr/>
+                    <a:lstStyle/>
+                    <a:p>
+                      <a:r>
+                        <a:rPr sz="1050">
+                          <a:solidFill>
+                            <a:srgbClr val="463A32"/>
+                          </a:solidFill>
+                        </a:rPr>
+                        <a:t>Farallones (local)</a:t>
+                      </a:r>
+                    </a:p>
+                  </a:txBody>
+                  <a:tcPr>
+                    <a:solidFill>
+                      <a:srgbClr val="F0E0C6"/>
+                    </a:solidFill>
+                  </a:tcPr>
+                </a:tc>
+                <a:tc>
+                  <a:txBody>
+                    <a:bodyPr/>
+                    <a:lstStyle/>
+                    <a:p>
+                      <a:r>
+                        <a:rPr sz="1050">
+                          <a:solidFill>
+                            <a:srgbClr val="463A32"/>
+                          </a:solidFill>
+                        </a:rPr>
+                        <a:t>desde $705.000</a:t>
+                      </a:r>
+                    </a:p>
+                  </a:txBody>
+                  <a:tcPr>
+                    <a:solidFill>
+                      <a:srgbClr val="F0E0C6"/>
+                    </a:solidFill>
+                  </a:tcPr>
+                </a:tc>
+                <a:tc>
+                  <a:txBody>
+                    <a:bodyPr/>
+                    <a:lstStyle/>
+                    <a:p>
+                      <a:pPr algn="ctr"/>
+                      <a:r>
+                        <a:rPr sz="1050">
+                          <a:solidFill>
+                            <a:srgbClr val="463A32"/>
+                          </a:solidFill>
+                        </a:rPr>
+                        <a:t>$100.714</a:t>
+                      </a:r>
+                    </a:p>
+                  </a:txBody>
+                  <a:tcPr>
+                    <a:solidFill>
+                      <a:srgbClr val="F0E0C6"/>
+                    </a:solidFill>
+                  </a:tcPr>
+                </a:tc>
+                <a:tc>
+                  <a:txBody>
+                    <a:bodyPr/>
+                    <a:lstStyle/>
+                    <a:p>
+                      <a:r>
+                        <a:rPr sz="1050">
+                          <a:solidFill>
+                            <a:srgbClr val="463A32"/>
+                          </a:solidFill>
+                        </a:rPr>
+                        <a:t>Sí — entrega coordinando el vuelo</a:t>
+                      </a:r>
+                    </a:p>
+                  </a:txBody>
+                  <a:tcPr>
+                    <a:solidFill>
+                      <a:srgbClr val="F0E0C6"/>
+                    </a:solidFill>
+                  </a:tcPr>
+                </a:tc>
+                <a:tc>
+                  <a:txBody>
+                    <a:bodyPr/>
+                    <a:lstStyle/>
+                    <a:p>
+                      <a:pPr algn="ctr"/>
+                      <a:r>
+                        <a:rPr sz="1050" u="sng">
+                          <a:solidFill>
+                            <a:srgbClr val="8F5A44"/>
+                          </a:solidFill>
+                          <a:hlinkClick r:id="rId3"/>
+                        </a:rPr>
+                        <a:t>ver</a:t>
+                      </a:r>
+                    </a:p>
+                  </a:txBody>
+                  <a:tcPr>
+                    <a:solidFill>
+                      <a:srgbClr val="F0E0C6"/>
+                    </a:solidFill>
+                  </a:tcPr>
+                </a:tc>
+              </a:tr>
+              <a:tr h="522514">
+                <a:tc>
+                  <a:txBody>
+                    <a:bodyPr/>
+                    <a:lstStyle/>
+                    <a:p>
+                      <a:r>
+                        <a:rPr sz="1050">
+                          <a:solidFill>
+                            <a:srgbClr val="463A32"/>
+                          </a:solidFill>
+                        </a:rPr>
+                        <a:t>7 puestos (varios modelos)</a:t>
+                      </a:r>
+                    </a:p>
+                  </a:txBody>
+                  <a:tcPr>
+                    <a:solidFill>
+                      <a:srgbClr val="F0E0C6"/>
+                    </a:solidFill>
+                  </a:tcPr>
+                </a:tc>
+                <a:tc>
+                  <a:txBody>
+                    <a:bodyPr/>
+                    <a:lstStyle/>
+                    <a:p>
+                      <a:r>
+                        <a:rPr sz="1050">
+                          <a:solidFill>
+                            <a:srgbClr val="463A32"/>
+                          </a:solidFill>
+                        </a:rPr>
+                        <a:t>WayCarCali (local)</a:t>
+                      </a:r>
+                    </a:p>
+                  </a:txBody>
+                  <a:tcPr>
+                    <a:solidFill>
+                      <a:srgbClr val="F0E0C6"/>
+                    </a:solidFill>
+                  </a:tcPr>
+                </a:tc>
+                <a:tc>
+                  <a:txBody>
+                    <a:bodyPr/>
+                    <a:lstStyle/>
+                    <a:p>
+                      <a:r>
+                        <a:rPr sz="1050">
+                          <a:solidFill>
+                            <a:srgbClr val="463A32"/>
+                          </a:solidFill>
+                        </a:rPr>
+                        <a:t>desde $360.000</a:t>
+                      </a:r>
+                    </a:p>
+                  </a:txBody>
+                  <a:tcPr>
+                    <a:solidFill>
+                      <a:srgbClr val="F0E0C6"/>
+                    </a:solidFill>
+                  </a:tcPr>
+                </a:tc>
+                <a:tc>
+                  <a:txBody>
+                    <a:bodyPr/>
+                    <a:lstStyle/>
+                    <a:p>
+                      <a:pPr algn="ctr"/>
+                      <a:r>
+                        <a:rPr sz="1050">
+                          <a:solidFill>
+                            <a:srgbClr val="463A32"/>
+                          </a:solidFill>
+                        </a:rPr>
+                        <a:t>$51.429</a:t>
+                      </a:r>
+                    </a:p>
+                  </a:txBody>
+                  <a:tcPr>
+                    <a:solidFill>
+                      <a:srgbClr val="F0E0C6"/>
+                    </a:solidFill>
+                  </a:tcPr>
+                </a:tc>
+                <a:tc>
+                  <a:txBody>
+                    <a:bodyPr/>
+                    <a:lstStyle/>
+                    <a:p>
+                      <a:r>
+                        <a:rPr sz="1050">
+                          <a:solidFill>
+                            <a:srgbClr val="463A32"/>
+                          </a:solidFill>
+                        </a:rPr>
+                        <a:t>Sí — domicilio gratis al aeropuerto (3+ días)</a:t>
+                      </a:r>
+                    </a:p>
+                  </a:txBody>
+                  <a:tcPr>
+                    <a:solidFill>
+                      <a:srgbClr val="F0E0C6"/>
+                    </a:solidFill>
+                  </a:tcPr>
+                </a:tc>
+                <a:tc>
+                  <a:txBody>
+                    <a:bodyPr/>
+                    <a:lstStyle/>
+                    <a:p>
+                      <a:pPr algn="ctr"/>
+                      <a:r>
+                        <a:rPr sz="1050" u="sng">
+                          <a:solidFill>
+                            <a:srgbClr val="8F5A44"/>
+                          </a:solidFill>
+                          <a:hlinkClick r:id="rId4"/>
+                        </a:rPr>
+                        <a:t>ver</a:t>
+                      </a:r>
+                    </a:p>
+                  </a:txBody>
+                  <a:tcPr>
+                    <a:solidFill>
+                      <a:srgbClr val="F0E0C6"/>
+                    </a:solidFill>
+                  </a:tcPr>
+                </a:tc>
+              </a:tr>
+              <a:tr h="522514">
+                <a:tc>
+                  <a:txBody>
+                    <a:bodyPr/>
+                    <a:lstStyle/>
+                    <a:p>
+                      <a:r>
+                        <a:rPr sz="1050">
+                          <a:solidFill>
+                            <a:srgbClr val="463A32"/>
+                          </a:solidFill>
+                        </a:rPr>
+                        <a:t>Nissan X-Trail</a:t>
+                      </a:r>
+                    </a:p>
+                  </a:txBody>
+                  <a:tcPr>
+                    <a:solidFill>
+                      <a:srgbClr val="EFE6DA"/>
+                    </a:solidFill>
+                  </a:tcPr>
+                </a:tc>
+                <a:tc>
+                  <a:txBody>
+                    <a:bodyPr/>
+                    <a:lstStyle/>
+                    <a:p>
+                      <a:r>
+                        <a:rPr sz="1050">
+                          <a:solidFill>
+                            <a:srgbClr val="463A32"/>
+                          </a:solidFill>
+                        </a:rPr>
+                        <a:t>Kayak · EconomyBookings</a:t>
+                      </a:r>
+                    </a:p>
+                  </a:txBody>
+                  <a:tcPr>
+                    <a:solidFill>
+                      <a:srgbClr val="EFE6DA"/>
+                    </a:solidFill>
+                  </a:tcPr>
+                </a:tc>
+                <a:tc>
+                  <a:txBody>
+                    <a:bodyPr/>
+                    <a:lstStyle/>
+                    <a:p>
+                      <a:r>
+                        <a:rPr sz="1050">
+                          <a:solidFill>
+                            <a:srgbClr val="463A32"/>
+                          </a:solidFill>
+                        </a:rPr>
+                        <a:t>$1.033.028</a:t>
+                      </a:r>
+                    </a:p>
+                  </a:txBody>
+                  <a:tcPr>
+                    <a:solidFill>
+                      <a:srgbClr val="EFE6DA"/>
+                    </a:solidFill>
+                  </a:tcPr>
+                </a:tc>
+                <a:tc>
+                  <a:txBody>
+                    <a:bodyPr/>
+                    <a:lstStyle/>
+                    <a:p>
+                      <a:pPr algn="ctr"/>
+                      <a:r>
+                        <a:rPr sz="1050">
+                          <a:solidFill>
+                            <a:srgbClr val="463A32"/>
+                          </a:solidFill>
+                        </a:rPr>
+                        <a:t>$147.575</a:t>
+                      </a:r>
+                    </a:p>
+                  </a:txBody>
+                  <a:tcPr>
+                    <a:solidFill>
+                      <a:srgbClr val="EFE6DA"/>
+                    </a:solidFill>
+                  </a:tcPr>
+                </a:tc>
+                <a:tc>
+                  <a:txBody>
+                    <a:bodyPr/>
+                    <a:lstStyle/>
+                    <a:p>
+                      <a:r>
+                        <a:rPr sz="1050">
+                          <a:solidFill>
+                            <a:srgbClr val="463A32"/>
+                          </a:solidFill>
+                        </a:rPr>
+                        <a:t>Mostrador: cierra ~10 pm</a:t>
+                      </a:r>
+                    </a:p>
+                  </a:txBody>
+                  <a:tcPr>
+                    <a:solidFill>
+                      <a:srgbClr val="EFE6DA"/>
+                    </a:solidFill>
+                  </a:tcPr>
+                </a:tc>
+                <a:tc>
+                  <a:txBody>
+                    <a:bodyPr/>
+                    <a:lstStyle/>
+                    <a:p>
+                      <a:pPr algn="ctr"/>
+                      <a:r>
+                        <a:rPr sz="1050" u="sng">
+                          <a:solidFill>
+                            <a:srgbClr val="8F5A44"/>
+                          </a:solidFill>
+                          <a:hlinkClick r:id="rId5"/>
+                        </a:rPr>
+                        <a:t>ver</a:t>
+                      </a:r>
+                    </a:p>
+                  </a:txBody>
+                  <a:tcPr>
+                    <a:solidFill>
+                      <a:srgbClr val="EFE6DA"/>
+                    </a:solidFill>
+                  </a:tcPr>
+                </a:tc>
+              </a:tr>
+              <a:tr h="522516">
+                <a:tc>
+                  <a:txBody>
+                    <a:bodyPr/>
+                    <a:lstStyle/>
+                    <a:p>
+                      <a:r>
+                        <a:rPr sz="1050">
+                          <a:solidFill>
+                            <a:srgbClr val="463A32"/>
+                          </a:solidFill>
+                        </a:rPr>
+                        <a:t>SUV mediano híbrido</a:t>
+                      </a:r>
+                    </a:p>
+                  </a:txBody>
+                  <a:tcPr>
+                    <a:solidFill>
+                      <a:srgbClr val="EFE6DA"/>
+                    </a:solidFill>
+                  </a:tcPr>
+                </a:tc>
+                <a:tc>
+                  <a:txBody>
+                    <a:bodyPr/>
+                    <a:lstStyle/>
+                    <a:p>
+                      <a:r>
+                        <a:rPr sz="1050">
+                          <a:solidFill>
+                            <a:srgbClr val="463A32"/>
+                          </a:solidFill>
+                        </a:rPr>
+                        <a:t>Kayak · Alkilautos</a:t>
+                      </a:r>
+                    </a:p>
+                  </a:txBody>
+                  <a:tcPr>
+                    <a:solidFill>
+                      <a:srgbClr val="EFE6DA"/>
+                    </a:solidFill>
+                  </a:tcPr>
+                </a:tc>
+                <a:tc>
+                  <a:txBody>
+                    <a:bodyPr/>
+                    <a:lstStyle/>
+                    <a:p>
+                      <a:r>
+                        <a:rPr sz="1050">
+                          <a:solidFill>
+                            <a:srgbClr val="463A32"/>
+                          </a:solidFill>
+                        </a:rPr>
+                        <a:t>$1.847.639</a:t>
+                      </a:r>
+                    </a:p>
+                  </a:txBody>
+                  <a:tcPr>
+                    <a:solidFill>
+                      <a:srgbClr val="EFE6DA"/>
+                    </a:solidFill>
+                  </a:tcPr>
+                </a:tc>
+                <a:tc>
+                  <a:txBody>
+                    <a:bodyPr/>
+                    <a:lstStyle/>
+                    <a:p>
+                      <a:pPr algn="ctr"/>
+                      <a:r>
+                        <a:rPr sz="1050">
+                          <a:solidFill>
+                            <a:srgbClr val="463A32"/>
+                          </a:solidFill>
+                        </a:rPr>
+                        <a:t>$263.948</a:t>
+                      </a:r>
+                    </a:p>
+                  </a:txBody>
+                  <a:tcPr>
+                    <a:solidFill>
+                      <a:srgbClr val="EFE6DA"/>
+                    </a:solidFill>
+                  </a:tcPr>
+                </a:tc>
+                <a:tc>
+                  <a:txBody>
+                    <a:bodyPr/>
+                    <a:lstStyle/>
+                    <a:p>
+                      <a:r>
+                        <a:rPr sz="1050">
+                          <a:solidFill>
+                            <a:srgbClr val="463A32"/>
+                          </a:solidFill>
+                        </a:rPr>
+                        <a:t>Mostrador: cierra ~10 pm</a:t>
+                      </a:r>
+                    </a:p>
+                  </a:txBody>
+                  <a:tcPr>
+                    <a:solidFill>
+                      <a:srgbClr val="EFE6DA"/>
+                    </a:solidFill>
+                  </a:tcPr>
+                </a:tc>
+                <a:tc>
+                  <a:txBody>
+                    <a:bodyPr/>
+                    <a:lstStyle/>
+                    <a:p>
+                      <a:pPr algn="ctr"/>
+                      <a:r>
+                        <a:rPr sz="1050" u="sng">
+                          <a:solidFill>
+                            <a:srgbClr val="8F5A44"/>
+                          </a:solidFill>
+                          <a:hlinkClick r:id="rId5"/>
+                        </a:rPr>
+                        <a:t>ver</a:t>
+                      </a:r>
+                    </a:p>
+                  </a:txBody>
+                  <a:tcPr>
+                    <a:solidFill>
+                      <a:srgbClr val="EFE6DA"/>
+                    </a:solidFill>
+                  </a:tcPr>
+                </a:tc>
+              </a:tr>
+            </a:tbl>
+          </a:graphicData>
+        </a:graphic>
+      </p:graphicFrame>
+      <p:sp>
+        <p:nvSpPr>
+          <p:cNvPr id="6" name="TextBox 5"/>
+          <p:cNvSpPr txBox="1"/>
+          <p:nvPr/>
+        </p:nvSpPr>
+        <p:spPr>
+          <a:xfrm>
+            <a:off x="457200" y="5577840"/>
+            <a:ext cx="11338560" cy="1097280"/>
+          </a:xfrm>
+          <a:prstGeom prst="rect">
+            <a:avLst/>
+          </a:prstGeom>
+          <a:noFill/>
+        </p:spPr>
+        <p:txBody>
+          <a:bodyPr wrap="square" anchor="t">
+            <a:spAutoFit/>
+          </a:bodyPr>
+          <a:lstStyle/>
+          <a:p>
+            <a:pPr algn="l"/>
+            <a:r>
+              <a:rPr sz="1150" b="0">
+                <a:solidFill>
+                  <a:srgbClr val="8F5A44"/>
+                </a:solidFill>
+              </a:rPr>
+              <a:t>Todos los precios son por los 3 días, solo el alquiler (sin gasolina ni parqueo). Las tarifas locales 'desde' se calculan sobre la tarifa base/día × 3; en alquiler corto el total real suele ser mayor (la Captiva, confirmada, cuesta ~$1.200.000) — pidan el exacto por WhatsApp. Lo clave sigue siendo el horario: las locales entregan coordinando el vuelo; los mostradores cierran ~10 pm.</a:t>
+            </a:r>
+          </a:p>
+        </p:txBody>
+      </p:sp>
+    </p:spTree>
+  </p:cSld>
+  <p:clrMapOvr>
+    <a:masterClrMapping/>
+  </p:clrMapOvr>
+</p:sld>
+</file>
+
+<file path=ppt/slides/slide11.xml><?xml version="1.0" encoding="utf-8"?>
+<p:sld xmlns:a="http://schemas.openxmlformats.org/drawingml/2006/main" xmlns:p="http://schemas.openxmlformats.org/presentationml/2006/main" xmlns:r="http://schemas.openxmlformats.org/officeDocument/2006/relationships">
+  <p:cSld>
+    <p:bg>
+      <p:bgPr>
+        <a:solidFill>
+          <a:srgbClr val="FCF5EC"/>
+        </a:solidFill>
+        <a:effectLst/>
+      </p:bgPr>
+    </p:bg>
+    <p:spTree>
+      <p:nvGrpSpPr>
+        <p:cNvPr id="1" name=""/>
+        <p:cNvGrpSpPr/>
+        <p:nvPr/>
+      </p:nvGrpSpPr>
+      <p:grpSpPr/>
+      <p:sp>
+        <p:nvSpPr>
           <p:cNvPr id="2" name="TextBox 1"/>
           <p:cNvSpPr txBox="1"/>
           <p:nvPr/>
@@ -4168,7 +5293,7 @@
 </p:sld>
 </file>
 
-<file path=ppt/slides/slide11.xml><?xml version="1.0" encoding="utf-8"?>
+<file path=ppt/slides/slide12.xml><?xml version="1.0" encoding="utf-8"?>
 <p:sld xmlns:a="http://schemas.openxmlformats.org/drawingml/2006/main" xmlns:p="http://schemas.openxmlformats.org/presentationml/2006/main" xmlns:r="http://schemas.openxmlformats.org/officeDocument/2006/relationships">
   <p:cSld>
     <p:bg>
@@ -8999,124 +10124,21 @@
                   <a:srgbClr val="FFFFFF"/>
                 </a:solidFill>
               </a:rPr>
-              <a:t>🌙   La llegada es de noche</a:t>
-            </a:r>
-          </a:p>
-        </p:txBody>
-      </p:sp>
-      <p:sp>
-        <p:nvSpPr>
-          <p:cNvPr id="4" name="Rounded Rectangle 3"/>
-          <p:cNvSpPr/>
-          <p:nvPr/>
-        </p:nvSpPr>
-        <p:spPr>
-          <a:xfrm>
-            <a:off x="502920" y="1508760"/>
-            <a:ext cx="3566160" cy="3566160"/>
-          </a:xfrm>
-          <a:prstGeom prst="roundRect">
-            <a:avLst>
-              <a:gd name="adj" fmla="val 12000"/>
-            </a:avLst>
-          </a:prstGeom>
-          <a:solidFill>
-            <a:srgbClr val="FFFFFF"/>
-          </a:solidFill>
-          <a:ln>
-            <a:noFill/>
-          </a:ln>
-          <a:effectLst>
-            <a:outerShdw blurRad="95000" dist="40000" dir="5400000" rotWithShape="0">
-              <a:srgbClr val="6E5B4E">
-                <a:alpha val="32000"/>
-              </a:srgbClr>
-            </a:outerShdw>
-          </a:effectLst>
-        </p:spPr>
-        <p:style>
-          <a:lnRef idx="1">
-            <a:schemeClr val="accent1"/>
-          </a:lnRef>
-          <a:fillRef idx="3">
-            <a:schemeClr val="accent1"/>
-          </a:fillRef>
-          <a:effectRef idx="2">
-            <a:schemeClr val="accent1"/>
-          </a:effectRef>
-          <a:fontRef idx="minor">
-            <a:schemeClr val="lt1"/>
-          </a:fontRef>
-        </p:style>
-        <p:txBody>
-          <a:bodyPr rtlCol="0" anchor="ctr"/>
-          <a:lstStyle/>
-          <a:p>
-            <a:pPr algn="ctr"/>
-          </a:p>
-        </p:txBody>
-      </p:sp>
-      <p:sp>
-        <p:nvSpPr>
-          <p:cNvPr id="5" name="Oval 4"/>
-          <p:cNvSpPr/>
-          <p:nvPr/>
-        </p:nvSpPr>
-        <p:spPr>
-          <a:xfrm>
-            <a:off x="1828800" y="1828800"/>
-            <a:ext cx="914400" cy="914400"/>
-          </a:xfrm>
-          <a:prstGeom prst="ellipse">
-            <a:avLst/>
-          </a:prstGeom>
-          <a:solidFill>
-            <a:srgbClr val="F0E0C6"/>
-          </a:solidFill>
-          <a:ln>
-            <a:noFill/>
-          </a:ln>
-        </p:spPr>
-        <p:style>
-          <a:lnRef idx="1">
-            <a:schemeClr val="accent1"/>
-          </a:lnRef>
-          <a:fillRef idx="3">
-            <a:schemeClr val="accent1"/>
-          </a:fillRef>
-          <a:effectRef idx="2">
-            <a:schemeClr val="accent1"/>
-          </a:effectRef>
-          <a:fontRef idx="minor">
-            <a:schemeClr val="lt1"/>
-          </a:fontRef>
-        </p:style>
-        <p:txBody>
-          <a:bodyPr rtlCol="0" anchor="ctr"/>
-          <a:lstStyle/>
-          <a:p>
-            <a:pPr algn="ctr"/>
-            <a:r>
-              <a:rPr sz="3000">
-                <a:solidFill>
-                  <a:srgbClr val="463A32"/>
-                </a:solidFill>
-              </a:rPr>
-              <a:t>🕘</a:t>
-            </a:r>
-          </a:p>
-        </p:txBody>
-      </p:sp>
-      <p:sp>
-        <p:nvSpPr>
-          <p:cNvPr id="6" name="TextBox 5"/>
+              <a:t>🛏️   Airbnb — casas enteras (baños del grupo)</a:t>
+            </a:r>
+          </a:p>
+        </p:txBody>
+      </p:sp>
+      <p:sp>
+        <p:nvSpPr>
+          <p:cNvPr id="4" name="TextBox 3"/>
           <p:cNvSpPr txBox="1"/>
           <p:nvPr/>
         </p:nvSpPr>
         <p:spPr>
           <a:xfrm>
-            <a:off x="777240" y="2880360"/>
-            <a:ext cx="3017520" cy="2103120"/>
+            <a:off x="548640" y="1097280"/>
+            <a:ext cx="11064240" cy="548640"/>
           </a:xfrm>
           <a:prstGeom prst="rect">
             <a:avLst/>
@@ -9129,155 +10151,718 @@
           </a:bodyPr>
           <a:lstStyle/>
           <a:p>
-            <a:pPr algn="ctr"/>
-            <a:r>
-              <a:rPr sz="1800" b="1">
-                <a:solidFill>
-                  <a:srgbClr val="8F5A44"/>
-                </a:solidFill>
-              </a:rPr>
-              <a:t>3 días limpios</a:t>
-            </a:r>
-          </a:p>
-          <a:p>
-            <a:pPr algn="ctr"/>
-            <a:r>
-              <a:rPr sz="600" b="0">
+            <a:pPr algn="l"/>
+            <a:r>
+              <a:rPr sz="1400" b="0">
                 <a:solidFill>
                   <a:srgbClr val="463A32"/>
                 </a:solidFill>
               </a:rPr>
-              <a:t/>
-            </a:r>
-          </a:p>
-          <a:p>
-            <a:pPr algn="ctr"/>
-            <a:r>
-              <a:rPr sz="1350" b="0">
-                <a:solidFill>
-                  <a:srgbClr val="463A32"/>
-                </a:solidFill>
-              </a:rPr>
-              <a:t>Recoger esa noche y devolver ~7 pm del 2: por debajo de las 72 h.</a:t>
-            </a:r>
-          </a:p>
-        </p:txBody>
-      </p:sp>
-      <p:sp>
-        <p:nvSpPr>
-          <p:cNvPr id="7" name="Rounded Rectangle 6"/>
-          <p:cNvSpPr/>
-          <p:nvPr/>
-        </p:nvSpPr>
-        <p:spPr>
-          <a:xfrm>
-            <a:off x="4233672" y="1508760"/>
-            <a:ext cx="3566160" cy="3566160"/>
-          </a:xfrm>
-          <a:prstGeom prst="roundRect">
-            <a:avLst>
-              <a:gd name="adj" fmla="val 12000"/>
-            </a:avLst>
-          </a:prstGeom>
-          <a:solidFill>
-            <a:srgbClr val="FFFFFF"/>
-          </a:solidFill>
-          <a:ln w="25400">
-            <a:solidFill>
-              <a:srgbClr val="D9A75E"/>
-            </a:solidFill>
-          </a:ln>
-          <a:effectLst>
-            <a:outerShdw blurRad="95000" dist="40000" dir="5400000" rotWithShape="0">
-              <a:srgbClr val="6E5B4E">
-                <a:alpha val="32000"/>
-              </a:srgbClr>
-            </a:outerShdw>
-          </a:effectLst>
-        </p:spPr>
-        <p:style>
-          <a:lnRef idx="1">
-            <a:schemeClr val="accent1"/>
-          </a:lnRef>
-          <a:fillRef idx="3">
-            <a:schemeClr val="accent1"/>
-          </a:fillRef>
-          <a:effectRef idx="2">
-            <a:schemeClr val="accent1"/>
-          </a:effectRef>
-          <a:fontRef idx="minor">
-            <a:schemeClr val="lt1"/>
-          </a:fontRef>
-        </p:style>
-        <p:txBody>
-          <a:bodyPr rtlCol="0" anchor="ctr"/>
-          <a:lstStyle/>
-          <a:p>
-            <a:pPr algn="ctr"/>
-          </a:p>
-        </p:txBody>
-      </p:sp>
-      <p:sp>
-        <p:nvSpPr>
-          <p:cNvPr id="8" name="Oval 7"/>
-          <p:cNvSpPr/>
-          <p:nvPr/>
-        </p:nvSpPr>
-        <p:spPr>
-          <a:xfrm>
-            <a:off x="5559552" y="1828800"/>
-            <a:ext cx="914400" cy="914400"/>
-          </a:xfrm>
-          <a:prstGeom prst="ellipse">
-            <a:avLst/>
-          </a:prstGeom>
-          <a:solidFill>
-            <a:srgbClr val="F0E0C6"/>
-          </a:solidFill>
-          <a:ln>
-            <a:noFill/>
-          </a:ln>
-        </p:spPr>
-        <p:style>
-          <a:lnRef idx="1">
-            <a:schemeClr val="accent1"/>
-          </a:lnRef>
-          <a:fillRef idx="3">
-            <a:schemeClr val="accent1"/>
-          </a:fillRef>
-          <a:effectRef idx="2">
-            <a:schemeClr val="accent1"/>
-          </a:effectRef>
-          <a:fontRef idx="minor">
-            <a:schemeClr val="lt1"/>
-          </a:fontRef>
-        </p:style>
-        <p:txBody>
-          <a:bodyPr rtlCol="0" anchor="ctr"/>
-          <a:lstStyle/>
-          <a:p>
-            <a:pPr algn="ctr"/>
-            <a:r>
-              <a:rPr sz="3000">
-                <a:solidFill>
-                  <a:srgbClr val="463A32"/>
-                </a:solidFill>
-              </a:rPr>
-              <a:t>✅</a:t>
-            </a:r>
-          </a:p>
-        </p:txBody>
-      </p:sp>
-      <p:sp>
-        <p:nvSpPr>
-          <p:cNvPr id="9" name="TextBox 8"/>
+              <a:t>Alojamiento entero: ningún baño se comparte con extraños. Casa entera recomendada + carro local ≈ $278.571 por persona (en meta). Barrido real, 7 personas.</a:t>
+            </a:r>
+          </a:p>
+        </p:txBody>
+      </p:sp>
+      <p:graphicFrame>
+        <p:nvGraphicFramePr>
+          <p:cNvPr id="5" name="Table 4"/>
+          <p:cNvGraphicFramePr>
+            <a:graphicFrameLocks noGrp="1"/>
+          </p:cNvGraphicFramePr>
+          <p:nvPr/>
+        </p:nvGraphicFramePr>
+        <p:xfrm>
+          <a:off x="457200" y="1783080"/>
+          <a:ext cx="11274552" cy="3291840"/>
+        </p:xfrm>
+        <a:graphic>
+          <a:graphicData uri="http://schemas.openxmlformats.org/drawingml/2006/table">
+            <a:tbl>
+              <a:tblPr firstRow="1" bandRow="1">
+                <a:tableStyleId>{5C22544A-7EE6-4342-B048-85BDC9FD1C3A}</a:tableStyleId>
+              </a:tblPr>
+              <a:tblGrid>
+                <a:gridCol w="4206240"/>
+                <a:gridCol w="1828800"/>
+                <a:gridCol w="1097280"/>
+                <a:gridCol w="1280160"/>
+                <a:gridCol w="2130552"/>
+                <a:gridCol w="731520"/>
+              </a:tblGrid>
+              <a:tr h="658368">
+                <a:tc>
+                  <a:txBody>
+                    <a:bodyPr/>
+                    <a:lstStyle/>
+                    <a:p>
+                      <a:r>
+                        <a:rPr b="1" sz="1200">
+                          <a:solidFill>
+                            <a:srgbClr val="FFFFFF"/>
+                          </a:solidFill>
+                        </a:rPr>
+                        <a:t>Casa / apto entero</a:t>
+                      </a:r>
+                    </a:p>
+                  </a:txBody>
+                  <a:tcPr>
+                    <a:solidFill>
+                      <a:srgbClr val="B5765C"/>
+                    </a:solidFill>
+                  </a:tcPr>
+                </a:tc>
+                <a:tc>
+                  <a:txBody>
+                    <a:bodyPr/>
+                    <a:lstStyle/>
+                    <a:p>
+                      <a:r>
+                        <a:rPr b="1" sz="1200">
+                          <a:solidFill>
+                            <a:srgbClr val="FFFFFF"/>
+                          </a:solidFill>
+                        </a:rPr>
+                        <a:t>Zona</a:t>
+                      </a:r>
+                    </a:p>
+                  </a:txBody>
+                  <a:tcPr>
+                    <a:solidFill>
+                      <a:srgbClr val="B5765C"/>
+                    </a:solidFill>
+                  </a:tcPr>
+                </a:tc>
+                <a:tc>
+                  <a:txBody>
+                    <a:bodyPr/>
+                    <a:lstStyle/>
+                    <a:p>
+                      <a:r>
+                        <a:rPr b="1" sz="1200">
+                          <a:solidFill>
+                            <a:srgbClr val="FFFFFF"/>
+                          </a:solidFill>
+                        </a:rPr>
+                        <a:t>Cabe</a:t>
+                      </a:r>
+                    </a:p>
+                  </a:txBody>
+                  <a:tcPr>
+                    <a:solidFill>
+                      <a:srgbClr val="B5765C"/>
+                    </a:solidFill>
+                  </a:tcPr>
+                </a:tc>
+                <a:tc>
+                  <a:txBody>
+                    <a:bodyPr/>
+                    <a:lstStyle/>
+                    <a:p>
+                      <a:r>
+                        <a:rPr b="1" sz="1200">
+                          <a:solidFill>
+                            <a:srgbClr val="FFFFFF"/>
+                          </a:solidFill>
+                        </a:rPr>
+                        <a:t>Baños</a:t>
+                      </a:r>
+                    </a:p>
+                  </a:txBody>
+                  <a:tcPr>
+                    <a:solidFill>
+                      <a:srgbClr val="B5765C"/>
+                    </a:solidFill>
+                  </a:tcPr>
+                </a:tc>
+                <a:tc>
+                  <a:txBody>
+                    <a:bodyPr/>
+                    <a:lstStyle/>
+                    <a:p>
+                      <a:r>
+                        <a:rPr b="1" sz="1200">
+                          <a:solidFill>
+                            <a:srgbClr val="FFFFFF"/>
+                          </a:solidFill>
+                        </a:rPr>
+                        <a:t>Por persona (3n)</a:t>
+                      </a:r>
+                    </a:p>
+                  </a:txBody>
+                  <a:tcPr>
+                    <a:solidFill>
+                      <a:srgbClr val="B5765C"/>
+                    </a:solidFill>
+                  </a:tcPr>
+                </a:tc>
+                <a:tc>
+                  <a:txBody>
+                    <a:bodyPr/>
+                    <a:lstStyle/>
+                    <a:p>
+                      <a:r>
+                        <a:rPr b="1" sz="1200">
+                          <a:solidFill>
+                            <a:srgbClr val="FFFFFF"/>
+                          </a:solidFill>
+                        </a:rPr>
+                        <a:t>Ver</a:t>
+                      </a:r>
+                    </a:p>
+                  </a:txBody>
+                  <a:tcPr>
+                    <a:solidFill>
+                      <a:srgbClr val="B5765C"/>
+                    </a:solidFill>
+                  </a:tcPr>
+                </a:tc>
+              </a:tr>
+              <a:tr h="658368">
+                <a:tc>
+                  <a:txBody>
+                    <a:bodyPr/>
+                    <a:lstStyle/>
+                    <a:p>
+                      <a:r>
+                        <a:rPr sz="1100">
+                          <a:solidFill>
+                            <a:srgbClr val="463A32"/>
+                          </a:solidFill>
+                        </a:rPr>
+                        <a:t>Casa de 4 Habitaciones – Terraza y Aire/C ★</a:t>
+                      </a:r>
+                    </a:p>
+                  </a:txBody>
+                  <a:tcPr>
+                    <a:solidFill>
+                      <a:srgbClr val="F0E0C6"/>
+                    </a:solidFill>
+                  </a:tcPr>
+                </a:tc>
+                <a:tc>
+                  <a:txBody>
+                    <a:bodyPr/>
+                    <a:lstStyle/>
+                    <a:p>
+                      <a:r>
+                        <a:rPr sz="1100">
+                          <a:solidFill>
+                            <a:srgbClr val="463A32"/>
+                          </a:solidFill>
+                        </a:rPr>
+                        <a:t>San Antonio</a:t>
+                      </a:r>
+                    </a:p>
+                  </a:txBody>
+                  <a:tcPr>
+                    <a:solidFill>
+                      <a:srgbClr val="F0E0C6"/>
+                    </a:solidFill>
+                  </a:tcPr>
+                </a:tc>
+                <a:tc>
+                  <a:txBody>
+                    <a:bodyPr/>
+                    <a:lstStyle/>
+                    <a:p>
+                      <a:pPr algn="ctr"/>
+                      <a:r>
+                        <a:rPr sz="1100">
+                          <a:solidFill>
+                            <a:srgbClr val="463A32"/>
+                          </a:solidFill>
+                        </a:rPr>
+                        <a:t>9</a:t>
+                      </a:r>
+                    </a:p>
+                  </a:txBody>
+                  <a:tcPr>
+                    <a:solidFill>
+                      <a:srgbClr val="F0E0C6"/>
+                    </a:solidFill>
+                  </a:tcPr>
+                </a:tc>
+                <a:tc>
+                  <a:txBody>
+                    <a:bodyPr/>
+                    <a:lstStyle/>
+                    <a:p>
+                      <a:pPr algn="ctr"/>
+                      <a:r>
+                        <a:rPr sz="1100">
+                          <a:solidFill>
+                            <a:srgbClr val="463A32"/>
+                          </a:solidFill>
+                        </a:rPr>
+                        <a:t>1,5</a:t>
+                      </a:r>
+                    </a:p>
+                  </a:txBody>
+                  <a:tcPr>
+                    <a:solidFill>
+                      <a:srgbClr val="F0E0C6"/>
+                    </a:solidFill>
+                  </a:tcPr>
+                </a:tc>
+                <a:tc>
+                  <a:txBody>
+                    <a:bodyPr/>
+                    <a:lstStyle/>
+                    <a:p>
+                      <a:pPr algn="ctr"/>
+                      <a:r>
+                        <a:rPr sz="1100">
+                          <a:solidFill>
+                            <a:srgbClr val="463A32"/>
+                          </a:solidFill>
+                        </a:rPr>
+                        <a:t>$78.571</a:t>
+                      </a:r>
+                    </a:p>
+                  </a:txBody>
+                  <a:tcPr>
+                    <a:solidFill>
+                      <a:srgbClr val="F0E0C6"/>
+                    </a:solidFill>
+                  </a:tcPr>
+                </a:tc>
+                <a:tc>
+                  <a:txBody>
+                    <a:bodyPr/>
+                    <a:lstStyle/>
+                    <a:p>
+                      <a:pPr algn="ctr"/>
+                      <a:r>
+                        <a:rPr sz="1100" u="sng">
+                          <a:solidFill>
+                            <a:srgbClr val="8F5A44"/>
+                          </a:solidFill>
+                          <a:hlinkClick r:id="rId2"/>
+                        </a:rPr>
+                        <a:t>ver</a:t>
+                      </a:r>
+                    </a:p>
+                  </a:txBody>
+                  <a:tcPr>
+                    <a:solidFill>
+                      <a:srgbClr val="F0E0C6"/>
+                    </a:solidFill>
+                  </a:tcPr>
+                </a:tc>
+              </a:tr>
+              <a:tr h="658368">
+                <a:tc>
+                  <a:txBody>
+                    <a:bodyPr/>
+                    <a:lstStyle/>
+                    <a:p>
+                      <a:r>
+                        <a:rPr sz="1100">
+                          <a:solidFill>
+                            <a:srgbClr val="463A32"/>
+                          </a:solidFill>
+                        </a:rPr>
+                        <a:t>Casa amoblada para 7 personas con garaje</a:t>
+                      </a:r>
+                    </a:p>
+                  </a:txBody>
+                  <a:tcPr>
+                    <a:solidFill>
+                      <a:srgbClr val="F4E8DA"/>
+                    </a:solidFill>
+                  </a:tcPr>
+                </a:tc>
+                <a:tc>
+                  <a:txBody>
+                    <a:bodyPr/>
+                    <a:lstStyle/>
+                    <a:p>
+                      <a:r>
+                        <a:rPr sz="1100">
+                          <a:solidFill>
+                            <a:srgbClr val="463A32"/>
+                          </a:solidFill>
+                        </a:rPr>
+                        <a:t>San Antonio</a:t>
+                      </a:r>
+                    </a:p>
+                  </a:txBody>
+                  <a:tcPr>
+                    <a:solidFill>
+                      <a:srgbClr val="F4E8DA"/>
+                    </a:solidFill>
+                  </a:tcPr>
+                </a:tc>
+                <a:tc>
+                  <a:txBody>
+                    <a:bodyPr/>
+                    <a:lstStyle/>
+                    <a:p>
+                      <a:pPr algn="ctr"/>
+                      <a:r>
+                        <a:rPr sz="1100">
+                          <a:solidFill>
+                            <a:srgbClr val="463A32"/>
+                          </a:solidFill>
+                        </a:rPr>
+                        <a:t>7</a:t>
+                      </a:r>
+                    </a:p>
+                  </a:txBody>
+                  <a:tcPr>
+                    <a:solidFill>
+                      <a:srgbClr val="F4E8DA"/>
+                    </a:solidFill>
+                  </a:tcPr>
+                </a:tc>
+                <a:tc>
+                  <a:txBody>
+                    <a:bodyPr/>
+                    <a:lstStyle/>
+                    <a:p>
+                      <a:pPr algn="ctr"/>
+                      <a:r>
+                        <a:rPr sz="1100">
+                          <a:solidFill>
+                            <a:srgbClr val="463A32"/>
+                          </a:solidFill>
+                        </a:rPr>
+                        <a:t>2,5</a:t>
+                      </a:r>
+                    </a:p>
+                  </a:txBody>
+                  <a:tcPr>
+                    <a:solidFill>
+                      <a:srgbClr val="F4E8DA"/>
+                    </a:solidFill>
+                  </a:tcPr>
+                </a:tc>
+                <a:tc>
+                  <a:txBody>
+                    <a:bodyPr/>
+                    <a:lstStyle/>
+                    <a:p>
+                      <a:pPr algn="ctr"/>
+                      <a:r>
+                        <a:rPr sz="1100">
+                          <a:solidFill>
+                            <a:srgbClr val="463A32"/>
+                          </a:solidFill>
+                        </a:rPr>
+                        <a:t>$90.714</a:t>
+                      </a:r>
+                    </a:p>
+                  </a:txBody>
+                  <a:tcPr>
+                    <a:solidFill>
+                      <a:srgbClr val="F4E8DA"/>
+                    </a:solidFill>
+                  </a:tcPr>
+                </a:tc>
+                <a:tc>
+                  <a:txBody>
+                    <a:bodyPr/>
+                    <a:lstStyle/>
+                    <a:p>
+                      <a:pPr algn="ctr"/>
+                      <a:r>
+                        <a:rPr sz="1100" u="sng">
+                          <a:solidFill>
+                            <a:srgbClr val="8F5A44"/>
+                          </a:solidFill>
+                          <a:hlinkClick r:id="rId3"/>
+                        </a:rPr>
+                        <a:t>ver</a:t>
+                      </a:r>
+                    </a:p>
+                  </a:txBody>
+                  <a:tcPr>
+                    <a:solidFill>
+                      <a:srgbClr val="F4E8DA"/>
+                    </a:solidFill>
+                  </a:tcPr>
+                </a:tc>
+              </a:tr>
+              <a:tr h="658368">
+                <a:tc>
+                  <a:txBody>
+                    <a:bodyPr/>
+                    <a:lstStyle/>
+                    <a:p>
+                      <a:r>
+                        <a:rPr sz="1100">
+                          <a:solidFill>
+                            <a:srgbClr val="463A32"/>
+                          </a:solidFill>
+                        </a:rPr>
+                        <a:t>Casa para 8 personas</a:t>
+                      </a:r>
+                    </a:p>
+                  </a:txBody>
+                  <a:tcPr>
+                    <a:solidFill>
+                      <a:srgbClr val="FFFFFF"/>
+                    </a:solidFill>
+                  </a:tcPr>
+                </a:tc>
+                <a:tc>
+                  <a:txBody>
+                    <a:bodyPr/>
+                    <a:lstStyle/>
+                    <a:p>
+                      <a:r>
+                        <a:rPr sz="1100">
+                          <a:solidFill>
+                            <a:srgbClr val="463A32"/>
+                          </a:solidFill>
+                        </a:rPr>
+                        <a:t>Granada</a:t>
+                      </a:r>
+                    </a:p>
+                  </a:txBody>
+                  <a:tcPr>
+                    <a:solidFill>
+                      <a:srgbClr val="FFFFFF"/>
+                    </a:solidFill>
+                  </a:tcPr>
+                </a:tc>
+                <a:tc>
+                  <a:txBody>
+                    <a:bodyPr/>
+                    <a:lstStyle/>
+                    <a:p>
+                      <a:pPr algn="ctr"/>
+                      <a:r>
+                        <a:rPr sz="1100">
+                          <a:solidFill>
+                            <a:srgbClr val="463A32"/>
+                          </a:solidFill>
+                        </a:rPr>
+                        <a:t>9</a:t>
+                      </a:r>
+                    </a:p>
+                  </a:txBody>
+                  <a:tcPr>
+                    <a:solidFill>
+                      <a:srgbClr val="FFFFFF"/>
+                    </a:solidFill>
+                  </a:tcPr>
+                </a:tc>
+                <a:tc>
+                  <a:txBody>
+                    <a:bodyPr/>
+                    <a:lstStyle/>
+                    <a:p>
+                      <a:pPr algn="ctr"/>
+                      <a:r>
+                        <a:rPr sz="1100">
+                          <a:solidFill>
+                            <a:srgbClr val="463A32"/>
+                          </a:solidFill>
+                        </a:rPr>
+                        <a:t>2</a:t>
+                      </a:r>
+                    </a:p>
+                  </a:txBody>
+                  <a:tcPr>
+                    <a:solidFill>
+                      <a:srgbClr val="FFFFFF"/>
+                    </a:solidFill>
+                  </a:tcPr>
+                </a:tc>
+                <a:tc>
+                  <a:txBody>
+                    <a:bodyPr/>
+                    <a:lstStyle/>
+                    <a:p>
+                      <a:pPr algn="ctr"/>
+                      <a:r>
+                        <a:rPr sz="1100">
+                          <a:solidFill>
+                            <a:srgbClr val="463A32"/>
+                          </a:solidFill>
+                        </a:rPr>
+                        <a:t>$124.151</a:t>
+                      </a:r>
+                    </a:p>
+                  </a:txBody>
+                  <a:tcPr>
+                    <a:solidFill>
+                      <a:srgbClr val="FFFFFF"/>
+                    </a:solidFill>
+                  </a:tcPr>
+                </a:tc>
+                <a:tc>
+                  <a:txBody>
+                    <a:bodyPr/>
+                    <a:lstStyle/>
+                    <a:p>
+                      <a:pPr algn="ctr"/>
+                      <a:r>
+                        <a:rPr sz="1100" u="sng">
+                          <a:solidFill>
+                            <a:srgbClr val="8F5A44"/>
+                          </a:solidFill>
+                          <a:hlinkClick r:id="rId4"/>
+                        </a:rPr>
+                        <a:t>ver</a:t>
+                      </a:r>
+                    </a:p>
+                  </a:txBody>
+                  <a:tcPr>
+                    <a:solidFill>
+                      <a:srgbClr val="FFFFFF"/>
+                    </a:solidFill>
+                  </a:tcPr>
+                </a:tc>
+              </a:tr>
+              <a:tr h="658368">
+                <a:tc>
+                  <a:txBody>
+                    <a:bodyPr/>
+                    <a:lstStyle/>
+                    <a:p>
+                      <a:r>
+                        <a:rPr sz="1100">
+                          <a:solidFill>
+                            <a:srgbClr val="463A32"/>
+                          </a:solidFill>
+                        </a:rPr>
+                        <a:t>Casa con piscina privada</a:t>
+                      </a:r>
+                    </a:p>
+                  </a:txBody>
+                  <a:tcPr>
+                    <a:solidFill>
+                      <a:srgbClr val="F4E8DA"/>
+                    </a:solidFill>
+                  </a:tcPr>
+                </a:tc>
+                <a:tc>
+                  <a:txBody>
+                    <a:bodyPr/>
+                    <a:lstStyle/>
+                    <a:p>
+                      <a:r>
+                        <a:rPr sz="1100">
+                          <a:solidFill>
+                            <a:srgbClr val="463A32"/>
+                          </a:solidFill>
+                        </a:rPr>
+                        <a:t>San Antonio</a:t>
+                      </a:r>
+                    </a:p>
+                  </a:txBody>
+                  <a:tcPr>
+                    <a:solidFill>
+                      <a:srgbClr val="F4E8DA"/>
+                    </a:solidFill>
+                  </a:tcPr>
+                </a:tc>
+                <a:tc>
+                  <a:txBody>
+                    <a:bodyPr/>
+                    <a:lstStyle/>
+                    <a:p>
+                      <a:pPr algn="ctr"/>
+                      <a:r>
+                        <a:rPr sz="1100">
+                          <a:solidFill>
+                            <a:srgbClr val="463A32"/>
+                          </a:solidFill>
+                        </a:rPr>
+                        <a:t>8</a:t>
+                      </a:r>
+                    </a:p>
+                  </a:txBody>
+                  <a:tcPr>
+                    <a:solidFill>
+                      <a:srgbClr val="F4E8DA"/>
+                    </a:solidFill>
+                  </a:tcPr>
+                </a:tc>
+                <a:tc>
+                  <a:txBody>
+                    <a:bodyPr/>
+                    <a:lstStyle/>
+                    <a:p>
+                      <a:pPr algn="ctr"/>
+                      <a:r>
+                        <a:rPr sz="1100">
+                          <a:solidFill>
+                            <a:srgbClr val="463A32"/>
+                          </a:solidFill>
+                        </a:rPr>
+                        <a:t>2,5</a:t>
+                      </a:r>
+                    </a:p>
+                  </a:txBody>
+                  <a:tcPr>
+                    <a:solidFill>
+                      <a:srgbClr val="F4E8DA"/>
+                    </a:solidFill>
+                  </a:tcPr>
+                </a:tc>
+                <a:tc>
+                  <a:txBody>
+                    <a:bodyPr/>
+                    <a:lstStyle/>
+                    <a:p>
+                      <a:pPr algn="ctr"/>
+                      <a:r>
+                        <a:rPr sz="1100">
+                          <a:solidFill>
+                            <a:srgbClr val="463A32"/>
+                          </a:solidFill>
+                        </a:rPr>
+                        <a:t>$430.608</a:t>
+                      </a:r>
+                    </a:p>
+                  </a:txBody>
+                  <a:tcPr>
+                    <a:solidFill>
+                      <a:srgbClr val="F4E8DA"/>
+                    </a:solidFill>
+                  </a:tcPr>
+                </a:tc>
+                <a:tc>
+                  <a:txBody>
+                    <a:bodyPr/>
+                    <a:lstStyle/>
+                    <a:p>
+                      <a:pPr algn="ctr"/>
+                      <a:r>
+                        <a:rPr sz="1100" u="sng">
+                          <a:solidFill>
+                            <a:srgbClr val="8F5A44"/>
+                          </a:solidFill>
+                          <a:hlinkClick r:id="rId5"/>
+                        </a:rPr>
+                        <a:t>ver</a:t>
+                      </a:r>
+                    </a:p>
+                  </a:txBody>
+                  <a:tcPr>
+                    <a:solidFill>
+                      <a:srgbClr val="F4E8DA"/>
+                    </a:solidFill>
+                  </a:tcPr>
+                </a:tc>
+              </a:tr>
+            </a:tbl>
+          </a:graphicData>
+        </a:graphic>
+      </p:graphicFrame>
+      <p:sp>
+        <p:nvSpPr>
+          <p:cNvPr id="6" name="TextBox 5"/>
           <p:cNvSpPr txBox="1"/>
           <p:nvPr/>
         </p:nvSpPr>
         <p:spPr>
           <a:xfrm>
-            <a:off x="4507992" y="2880360"/>
-            <a:ext cx="3017520" cy="2103120"/>
+            <a:off x="548640" y="5440680"/>
+            <a:ext cx="11064240" cy="548640"/>
           </a:xfrm>
           <a:prstGeom prst="rect">
             <a:avLst/>
@@ -9292,227 +10877,12 @@
           <a:p>
             <a:pPr algn="ctr"/>
             <a:r>
-              <a:rPr sz="1800" b="1">
-                <a:solidFill>
-                  <a:srgbClr val="8F5A44"/>
-                </a:solidFill>
-              </a:rPr>
-              <a:t>Local = cuadra</a:t>
-            </a:r>
-          </a:p>
-          <a:p>
-            <a:pPr algn="ctr"/>
-            <a:r>
-              <a:rPr sz="600" b="0">
-                <a:solidFill>
-                  <a:srgbClr val="463A32"/>
-                </a:solidFill>
-              </a:rPr>
-              <a:t/>
-            </a:r>
-          </a:p>
-          <a:p>
-            <a:pPr algn="ctr"/>
-            <a:r>
-              <a:rPr sz="1350" b="0">
-                <a:solidFill>
-                  <a:srgbClr val="463A32"/>
-                </a:solidFill>
-              </a:rPr>
-              <a:t>Farallones / WayCarCali entregan el carro coordinando el vuelo de las 8 pm.</a:t>
-            </a:r>
-          </a:p>
-        </p:txBody>
-      </p:sp>
-      <p:sp>
-        <p:nvSpPr>
-          <p:cNvPr id="10" name="Rounded Rectangle 9"/>
-          <p:cNvSpPr/>
-          <p:nvPr/>
-        </p:nvSpPr>
-        <p:spPr>
-          <a:xfrm>
-            <a:off x="7964424" y="1508760"/>
-            <a:ext cx="3566160" cy="3566160"/>
-          </a:xfrm>
-          <a:prstGeom prst="roundRect">
-            <a:avLst>
-              <a:gd name="adj" fmla="val 12000"/>
-            </a:avLst>
-          </a:prstGeom>
-          <a:solidFill>
-            <a:srgbClr val="FFFFFF"/>
-          </a:solidFill>
-          <a:ln>
-            <a:noFill/>
-          </a:ln>
-          <a:effectLst>
-            <a:outerShdw blurRad="95000" dist="40000" dir="5400000" rotWithShape="0">
-              <a:srgbClr val="6E5B4E">
-                <a:alpha val="32000"/>
-              </a:srgbClr>
-            </a:outerShdw>
-          </a:effectLst>
-        </p:spPr>
-        <p:style>
-          <a:lnRef idx="1">
-            <a:schemeClr val="accent1"/>
-          </a:lnRef>
-          <a:fillRef idx="3">
-            <a:schemeClr val="accent1"/>
-          </a:fillRef>
-          <a:effectRef idx="2">
-            <a:schemeClr val="accent1"/>
-          </a:effectRef>
-          <a:fontRef idx="minor">
-            <a:schemeClr val="lt1"/>
-          </a:fontRef>
-        </p:style>
-        <p:txBody>
-          <a:bodyPr rtlCol="0" anchor="ctr"/>
-          <a:lstStyle/>
-          <a:p>
-            <a:pPr algn="ctr"/>
-          </a:p>
-        </p:txBody>
-      </p:sp>
-      <p:sp>
-        <p:nvSpPr>
-          <p:cNvPr id="11" name="Oval 10"/>
-          <p:cNvSpPr/>
-          <p:nvPr/>
-        </p:nvSpPr>
-        <p:spPr>
-          <a:xfrm>
-            <a:off x="9290304" y="1828800"/>
-            <a:ext cx="914400" cy="914400"/>
-          </a:xfrm>
-          <a:prstGeom prst="ellipse">
-            <a:avLst/>
-          </a:prstGeom>
-          <a:solidFill>
-            <a:srgbClr val="F0E0C6"/>
-          </a:solidFill>
-          <a:ln>
-            <a:noFill/>
-          </a:ln>
-        </p:spPr>
-        <p:style>
-          <a:lnRef idx="1">
-            <a:schemeClr val="accent1"/>
-          </a:lnRef>
-          <a:fillRef idx="3">
-            <a:schemeClr val="accent1"/>
-          </a:fillRef>
-          <a:effectRef idx="2">
-            <a:schemeClr val="accent1"/>
-          </a:effectRef>
-          <a:fontRef idx="minor">
-            <a:schemeClr val="lt1"/>
-          </a:fontRef>
-        </p:style>
-        <p:txBody>
-          <a:bodyPr rtlCol="0" anchor="ctr"/>
-          <a:lstStyle/>
-          <a:p>
-            <a:pPr algn="ctr"/>
-            <a:r>
-              <a:rPr sz="3000">
-                <a:solidFill>
-                  <a:srgbClr val="463A32"/>
-                </a:solidFill>
-              </a:rPr>
-              <a:t>⚠️</a:t>
-            </a:r>
-          </a:p>
-        </p:txBody>
-      </p:sp>
-      <p:sp>
-        <p:nvSpPr>
-          <p:cNvPr id="12" name="TextBox 11"/>
-          <p:cNvSpPr txBox="1"/>
-          <p:nvPr/>
-        </p:nvSpPr>
-        <p:spPr>
-          <a:xfrm>
-            <a:off x="8238744" y="2880360"/>
-            <a:ext cx="3017520" cy="2103120"/>
-          </a:xfrm>
-          <a:prstGeom prst="rect">
-            <a:avLst/>
-          </a:prstGeom>
-          <a:noFill/>
-        </p:spPr>
-        <p:txBody>
-          <a:bodyPr wrap="square" anchor="t">
-            <a:spAutoFit/>
-          </a:bodyPr>
-          <a:lstStyle/>
-          <a:p>
-            <a:pPr algn="ctr"/>
-            <a:r>
-              <a:rPr sz="1800" b="1">
-                <a:solidFill>
-                  <a:srgbClr val="8F5A44"/>
-                </a:solidFill>
-              </a:rPr>
-              <a:t>Mostrador = ojo</a:t>
-            </a:r>
-          </a:p>
-          <a:p>
-            <a:pPr algn="ctr"/>
-            <a:r>
-              <a:rPr sz="600" b="0">
-                <a:solidFill>
-                  <a:srgbClr val="463A32"/>
-                </a:solidFill>
-              </a:rPr>
-              <a:t/>
-            </a:r>
-          </a:p>
-          <a:p>
-            <a:pPr algn="ctr"/>
-            <a:r>
-              <a:rPr sz="1350" b="0">
-                <a:solidFill>
-                  <a:srgbClr val="463A32"/>
-                </a:solidFill>
-              </a:rPr>
-              <a:t>Alamo / Localiza: más baratos, pero cierran ~10 pm. Reservar fuera de horario (24 h).</a:t>
-            </a:r>
-          </a:p>
-        </p:txBody>
-      </p:sp>
-      <p:sp>
-        <p:nvSpPr>
-          <p:cNvPr id="13" name="TextBox 12"/>
-          <p:cNvSpPr txBox="1"/>
-          <p:nvPr/>
-        </p:nvSpPr>
-        <p:spPr>
-          <a:xfrm>
-            <a:off x="548640" y="5303520"/>
-            <a:ext cx="11064240" cy="548640"/>
-          </a:xfrm>
-          <a:prstGeom prst="rect">
-            <a:avLst/>
-          </a:prstGeom>
-          <a:noFill/>
-        </p:spPr>
-        <p:txBody>
-          <a:bodyPr wrap="square" anchor="t">
-            <a:spAutoFit/>
-          </a:bodyPr>
-          <a:lstStyle/>
-          <a:p>
-            <a:pPr algn="ctr"/>
-            <a:r>
-              <a:rPr sz="1300" b="0">
+              <a:rPr sz="1200" b="0">
                 <a:solidFill>
                   <a:srgbClr val="8A7A6E"/>
                 </a:solidFill>
               </a:rPr>
-              <a:t>Red de seguridad: los taxis oficiales del aeropuerto operan 24/7 (distintivo amarillo, tarifados).</a:t>
+              <a:t>No cumplen: «Casa Familiar 5 Hab» (1 baño para 11) y «Apto El Ingenio» (3 camas, lejos de la rumba). Por eso se miran baños y camas, no solo el precio.</a:t>
             </a:r>
           </a:p>
         </p:txBody>
@@ -9624,7 +10994,7 @@
                   <a:srgbClr val="FFFFFF"/>
                 </a:solidFill>
               </a:rPr>
-              <a:t>🚗   Cómo moverse — tres opciones</a:t>
+              <a:t>🌙   La llegada es de noche</a:t>
             </a:r>
           </a:p>
         </p:txBody>
@@ -9637,8 +11007,8 @@
         </p:nvSpPr>
         <p:spPr>
           <a:xfrm>
-            <a:off x="502920" y="1554480"/>
-            <a:ext cx="3566160" cy="4114800"/>
+            <a:off x="502920" y="1508760"/>
+            <a:ext cx="3566160" cy="3566160"/>
           </a:xfrm>
           <a:prstGeom prst="roundRect">
             <a:avLst>
@@ -9646,7 +11016,166 @@
             </a:avLst>
           </a:prstGeom>
           <a:solidFill>
+            <a:srgbClr val="FFFFFF"/>
+          </a:solidFill>
+          <a:ln>
+            <a:noFill/>
+          </a:ln>
+          <a:effectLst>
+            <a:outerShdw blurRad="95000" dist="40000" dir="5400000" rotWithShape="0">
+              <a:srgbClr val="6E5B4E">
+                <a:alpha val="32000"/>
+              </a:srgbClr>
+            </a:outerShdw>
+          </a:effectLst>
+        </p:spPr>
+        <p:style>
+          <a:lnRef idx="1">
+            <a:schemeClr val="accent1"/>
+          </a:lnRef>
+          <a:fillRef idx="3">
+            <a:schemeClr val="accent1"/>
+          </a:fillRef>
+          <a:effectRef idx="2">
+            <a:schemeClr val="accent1"/>
+          </a:effectRef>
+          <a:fontRef idx="minor">
+            <a:schemeClr val="lt1"/>
+          </a:fontRef>
+        </p:style>
+        <p:txBody>
+          <a:bodyPr rtlCol="0" anchor="ctr"/>
+          <a:lstStyle/>
+          <a:p>
+            <a:pPr algn="ctr"/>
+          </a:p>
+        </p:txBody>
+      </p:sp>
+      <p:sp>
+        <p:nvSpPr>
+          <p:cNvPr id="5" name="Oval 4"/>
+          <p:cNvSpPr/>
+          <p:nvPr/>
+        </p:nvSpPr>
+        <p:spPr>
+          <a:xfrm>
+            <a:off x="1828800" y="1828800"/>
+            <a:ext cx="914400" cy="914400"/>
+          </a:xfrm>
+          <a:prstGeom prst="ellipse">
+            <a:avLst/>
+          </a:prstGeom>
+          <a:solidFill>
             <a:srgbClr val="F0E0C6"/>
+          </a:solidFill>
+          <a:ln>
+            <a:noFill/>
+          </a:ln>
+        </p:spPr>
+        <p:style>
+          <a:lnRef idx="1">
+            <a:schemeClr val="accent1"/>
+          </a:lnRef>
+          <a:fillRef idx="3">
+            <a:schemeClr val="accent1"/>
+          </a:fillRef>
+          <a:effectRef idx="2">
+            <a:schemeClr val="accent1"/>
+          </a:effectRef>
+          <a:fontRef idx="minor">
+            <a:schemeClr val="lt1"/>
+          </a:fontRef>
+        </p:style>
+        <p:txBody>
+          <a:bodyPr rtlCol="0" anchor="ctr"/>
+          <a:lstStyle/>
+          <a:p>
+            <a:pPr algn="ctr"/>
+            <a:r>
+              <a:rPr sz="3000">
+                <a:solidFill>
+                  <a:srgbClr val="463A32"/>
+                </a:solidFill>
+              </a:rPr>
+              <a:t>🕘</a:t>
+            </a:r>
+          </a:p>
+        </p:txBody>
+      </p:sp>
+      <p:sp>
+        <p:nvSpPr>
+          <p:cNvPr id="6" name="TextBox 5"/>
+          <p:cNvSpPr txBox="1"/>
+          <p:nvPr/>
+        </p:nvSpPr>
+        <p:spPr>
+          <a:xfrm>
+            <a:off x="777240" y="2880360"/>
+            <a:ext cx="3017520" cy="2103120"/>
+          </a:xfrm>
+          <a:prstGeom prst="rect">
+            <a:avLst/>
+          </a:prstGeom>
+          <a:noFill/>
+        </p:spPr>
+        <p:txBody>
+          <a:bodyPr wrap="square" anchor="t">
+            <a:spAutoFit/>
+          </a:bodyPr>
+          <a:lstStyle/>
+          <a:p>
+            <a:pPr algn="ctr"/>
+            <a:r>
+              <a:rPr sz="1800" b="1">
+                <a:solidFill>
+                  <a:srgbClr val="8F5A44"/>
+                </a:solidFill>
+              </a:rPr>
+              <a:t>3 días limpios</a:t>
+            </a:r>
+          </a:p>
+          <a:p>
+            <a:pPr algn="ctr"/>
+            <a:r>
+              <a:rPr sz="600" b="0">
+                <a:solidFill>
+                  <a:srgbClr val="463A32"/>
+                </a:solidFill>
+              </a:rPr>
+              <a:t/>
+            </a:r>
+          </a:p>
+          <a:p>
+            <a:pPr algn="ctr"/>
+            <a:r>
+              <a:rPr sz="1350" b="0">
+                <a:solidFill>
+                  <a:srgbClr val="463A32"/>
+                </a:solidFill>
+              </a:rPr>
+              <a:t>Recoger esa noche y devolver ~7 pm del 2: por debajo de las 72 h.</a:t>
+            </a:r>
+          </a:p>
+        </p:txBody>
+      </p:sp>
+      <p:sp>
+        <p:nvSpPr>
+          <p:cNvPr id="7" name="Rounded Rectangle 6"/>
+          <p:cNvSpPr/>
+          <p:nvPr/>
+        </p:nvSpPr>
+        <p:spPr>
+          <a:xfrm>
+            <a:off x="4233672" y="1508760"/>
+            <a:ext cx="3566160" cy="3566160"/>
+          </a:xfrm>
+          <a:prstGeom prst="roundRect">
+            <a:avLst>
+              <a:gd name="adj" fmla="val 12000"/>
+            </a:avLst>
+          </a:prstGeom>
+          <a:solidFill>
+            <a:srgbClr val="FFFFFF"/>
           </a:solidFill>
           <a:ln w="25400">
             <a:solidFill>
@@ -9685,22 +11214,20 @@
       </p:sp>
       <p:sp>
         <p:nvSpPr>
-          <p:cNvPr id="5" name="Rounded Rectangle 4"/>
+          <p:cNvPr id="8" name="Oval 7"/>
           <p:cNvSpPr/>
           <p:nvPr/>
         </p:nvSpPr>
         <p:spPr>
           <a:xfrm>
-            <a:off x="1508760" y="1325880"/>
-            <a:ext cx="1554480" cy="457200"/>
-          </a:xfrm>
-          <a:prstGeom prst="roundRect">
-            <a:avLst>
-              <a:gd name="adj" fmla="val 50000"/>
-            </a:avLst>
+            <a:off x="5559552" y="1828800"/>
+            <a:ext cx="914400" cy="914400"/>
+          </a:xfrm>
+          <a:prstGeom prst="ellipse">
+            <a:avLst/>
           </a:prstGeom>
           <a:solidFill>
-            <a:srgbClr val="D9A75E"/>
+            <a:srgbClr val="F0E0C6"/>
           </a:solidFill>
           <a:ln>
             <a:noFill/>
@@ -9725,53 +11252,27 @@
           <a:lstStyle/>
           <a:p>
             <a:pPr algn="ctr"/>
-          </a:p>
-        </p:txBody>
-      </p:sp>
-      <p:sp>
-        <p:nvSpPr>
-          <p:cNvPr id="6" name="TextBox 5"/>
+            <a:r>
+              <a:rPr sz="3000">
+                <a:solidFill>
+                  <a:srgbClr val="463A32"/>
+                </a:solidFill>
+              </a:rPr>
+              <a:t>✅</a:t>
+            </a:r>
+          </a:p>
+        </p:txBody>
+      </p:sp>
+      <p:sp>
+        <p:nvSpPr>
+          <p:cNvPr id="9" name="TextBox 8"/>
           <p:cNvSpPr txBox="1"/>
           <p:nvPr/>
         </p:nvSpPr>
         <p:spPr>
           <a:xfrm>
-            <a:off x="1508760" y="1325880"/>
-            <a:ext cx="1554480" cy="457200"/>
-          </a:xfrm>
-          <a:prstGeom prst="rect">
-            <a:avLst/>
-          </a:prstGeom>
-          <a:noFill/>
-        </p:spPr>
-        <p:txBody>
-          <a:bodyPr wrap="square" anchor="ctr">
-            <a:spAutoFit/>
-          </a:bodyPr>
-          <a:lstStyle/>
-          <a:p>
-            <a:pPr algn="ctr"/>
-            <a:r>
-              <a:rPr sz="1200" b="1">
-                <a:solidFill>
-                  <a:srgbClr val="463A32"/>
-                </a:solidFill>
-              </a:rPr>
-              <a:t>★ Recomendado</a:t>
-            </a:r>
-          </a:p>
-        </p:txBody>
-      </p:sp>
-      <p:sp>
-        <p:nvSpPr>
-          <p:cNvPr id="7" name="TextBox 6"/>
-          <p:cNvSpPr txBox="1"/>
-          <p:nvPr/>
-        </p:nvSpPr>
-        <p:spPr>
-          <a:xfrm>
-            <a:off x="777240" y="1920240"/>
-            <a:ext cx="3017520" cy="731520"/>
+            <a:off x="4507992" y="2880360"/>
+            <a:ext cx="3017520" cy="2103120"/>
           </a:xfrm>
           <a:prstGeom prst="rect">
             <a:avLst/>
@@ -9791,86 +11292,29 @@
                   <a:srgbClr val="8F5A44"/>
                 </a:solidFill>
               </a:rPr>
-              <a:t>Carro local (entrega)</a:t>
-            </a:r>
-          </a:p>
-        </p:txBody>
-      </p:sp>
-      <p:sp>
-        <p:nvSpPr>
-          <p:cNvPr id="8" name="TextBox 7"/>
-          <p:cNvSpPr txBox="1"/>
-          <p:nvPr/>
-        </p:nvSpPr>
-        <p:spPr>
-          <a:xfrm>
-            <a:off x="777240" y="2743200"/>
-            <a:ext cx="3017520" cy="1005840"/>
-          </a:xfrm>
-          <a:prstGeom prst="rect">
-            <a:avLst/>
-          </a:prstGeom>
-          <a:noFill/>
-        </p:spPr>
-        <p:txBody>
-          <a:bodyPr wrap="square" anchor="t">
-            <a:spAutoFit/>
-          </a:bodyPr>
-          <a:lstStyle/>
+              <a:t>Local = cuadra</a:t>
+            </a:r>
+          </a:p>
           <a:p>
             <a:pPr algn="ctr"/>
             <a:r>
-              <a:rPr sz="3400" b="1">
-                <a:solidFill>
-                  <a:srgbClr val="D9A75E"/>
-                </a:solidFill>
-              </a:rPr>
-              <a:t>$200.000</a:t>
+              <a:rPr sz="600" b="0">
+                <a:solidFill>
+                  <a:srgbClr val="463A32"/>
+                </a:solidFill>
+              </a:rPr>
+              <a:t/>
             </a:r>
           </a:p>
           <a:p>
             <a:pPr algn="ctr"/>
             <a:r>
-              <a:rPr sz="1300" b="0">
-                <a:solidFill>
-                  <a:srgbClr val="8A7A6E"/>
-                </a:solidFill>
-              </a:rPr>
-              <a:t>por persona</a:t>
-            </a:r>
-          </a:p>
-        </p:txBody>
-      </p:sp>
-      <p:sp>
-        <p:nvSpPr>
-          <p:cNvPr id="9" name="TextBox 8"/>
-          <p:cNvSpPr txBox="1"/>
-          <p:nvPr/>
-        </p:nvSpPr>
-        <p:spPr>
-          <a:xfrm>
-            <a:off x="822960" y="4069080"/>
-            <a:ext cx="2926080" cy="1463040"/>
-          </a:xfrm>
-          <a:prstGeom prst="rect">
-            <a:avLst/>
-          </a:prstGeom>
-          <a:noFill/>
-        </p:spPr>
-        <p:txBody>
-          <a:bodyPr wrap="square" anchor="t">
-            <a:spAutoFit/>
-          </a:bodyPr>
-          <a:lstStyle/>
-          <a:p>
-            <a:pPr algn="ctr"/>
-            <a:r>
               <a:rPr sz="1350" b="0">
                 <a:solidFill>
                   <a:srgbClr val="463A32"/>
                 </a:solidFill>
               </a:rPr>
-              <a:t>Cuadra con la llegada de noche; libertad para salir de Cali.</a:t>
+              <a:t>Farallones / WayCarCali entregan el carro coordinando el vuelo de las 8 pm.</a:t>
             </a:r>
           </a:p>
         </p:txBody>
@@ -9883,8 +11327,8 @@
         </p:nvSpPr>
         <p:spPr>
           <a:xfrm>
-            <a:off x="4233672" y="1554480"/>
-            <a:ext cx="3566160" cy="4114800"/>
+            <a:off x="7964424" y="1508760"/>
+            <a:ext cx="3566160" cy="3566160"/>
           </a:xfrm>
           <a:prstGeom prst="roundRect">
             <a:avLst>
@@ -9929,146 +11373,24 @@
       </p:sp>
       <p:sp>
         <p:nvSpPr>
-          <p:cNvPr id="11" name="TextBox 10"/>
-          <p:cNvSpPr txBox="1"/>
-          <p:nvPr/>
-        </p:nvSpPr>
-        <p:spPr>
-          <a:xfrm>
-            <a:off x="4507992" y="1920240"/>
-            <a:ext cx="3017520" cy="731520"/>
-          </a:xfrm>
-          <a:prstGeom prst="rect">
+          <p:cNvPr id="11" name="Oval 10"/>
+          <p:cNvSpPr/>
+          <p:nvPr/>
+        </p:nvSpPr>
+        <p:spPr>
+          <a:xfrm>
+            <a:off x="9290304" y="1828800"/>
+            <a:ext cx="914400" cy="914400"/>
+          </a:xfrm>
+          <a:prstGeom prst="ellipse">
             <a:avLst/>
           </a:prstGeom>
-          <a:noFill/>
-        </p:spPr>
-        <p:txBody>
-          <a:bodyPr wrap="square" anchor="t">
-            <a:spAutoFit/>
-          </a:bodyPr>
-          <a:lstStyle/>
-          <a:p>
-            <a:pPr algn="ctr"/>
-            <a:r>
-              <a:rPr sz="1800" b="1">
-                <a:solidFill>
-                  <a:srgbClr val="8F5A44"/>
-                </a:solidFill>
-              </a:rPr>
-              <a:t>Mostrador (Kayak)</a:t>
-            </a:r>
-          </a:p>
-        </p:txBody>
-      </p:sp>
-      <p:sp>
-        <p:nvSpPr>
-          <p:cNvPr id="12" name="TextBox 11"/>
-          <p:cNvSpPr txBox="1"/>
-          <p:nvPr/>
-        </p:nvSpPr>
-        <p:spPr>
-          <a:xfrm>
-            <a:off x="4507992" y="2743200"/>
-            <a:ext cx="3017520" cy="1005840"/>
-          </a:xfrm>
-          <a:prstGeom prst="rect">
-            <a:avLst/>
-          </a:prstGeom>
-          <a:noFill/>
-        </p:spPr>
-        <p:txBody>
-          <a:bodyPr wrap="square" anchor="t">
-            <a:spAutoFit/>
-          </a:bodyPr>
-          <a:lstStyle/>
-          <a:p>
-            <a:pPr algn="ctr"/>
-            <a:r>
-              <a:rPr sz="3400" b="1">
-                <a:solidFill>
-                  <a:srgbClr val="D9A75E"/>
-                </a:solidFill>
-              </a:rPr>
-              <a:t>$180.000</a:t>
-            </a:r>
-          </a:p>
-          <a:p>
-            <a:pPr algn="ctr"/>
-            <a:r>
-              <a:rPr sz="1300" b="0">
-                <a:solidFill>
-                  <a:srgbClr val="8A7A6E"/>
-                </a:solidFill>
-              </a:rPr>
-              <a:t>por persona</a:t>
-            </a:r>
-          </a:p>
-        </p:txBody>
-      </p:sp>
-      <p:sp>
-        <p:nvSpPr>
-          <p:cNvPr id="13" name="TextBox 12"/>
-          <p:cNvSpPr txBox="1"/>
-          <p:nvPr/>
-        </p:nvSpPr>
-        <p:spPr>
-          <a:xfrm>
-            <a:off x="4553712" y="4069080"/>
-            <a:ext cx="2926080" cy="1463040"/>
-          </a:xfrm>
-          <a:prstGeom prst="rect">
-            <a:avLst/>
-          </a:prstGeom>
-          <a:noFill/>
-        </p:spPr>
-        <p:txBody>
-          <a:bodyPr wrap="square" anchor="t">
-            <a:spAutoFit/>
-          </a:bodyPr>
-          <a:lstStyle/>
-          <a:p>
-            <a:pPr algn="ctr"/>
-            <a:r>
-              <a:rPr sz="1350" b="0">
-                <a:solidFill>
-                  <a:srgbClr val="463A32"/>
-                </a:solidFill>
-              </a:rPr>
-              <a:t>Más barato, pero el mostrador cierra ~10 pm.</a:t>
-            </a:r>
-          </a:p>
-        </p:txBody>
-      </p:sp>
-      <p:sp>
-        <p:nvSpPr>
-          <p:cNvPr id="14" name="Rounded Rectangle 13"/>
-          <p:cNvSpPr/>
-          <p:nvPr/>
-        </p:nvSpPr>
-        <p:spPr>
-          <a:xfrm>
-            <a:off x="7964424" y="1554480"/>
-            <a:ext cx="3566160" cy="4114800"/>
-          </a:xfrm>
-          <a:prstGeom prst="roundRect">
-            <a:avLst>
-              <a:gd name="adj" fmla="val 12000"/>
-            </a:avLst>
-          </a:prstGeom>
           <a:solidFill>
-            <a:srgbClr val="FFFFFF"/>
+            <a:srgbClr val="F0E0C6"/>
           </a:solidFill>
           <a:ln>
             <a:noFill/>
           </a:ln>
-          <a:effectLst>
-            <a:outerShdw blurRad="95000" dist="40000" dir="5400000" rotWithShape="0">
-              <a:srgbClr val="6E5B4E">
-                <a:alpha val="32000"/>
-              </a:srgbClr>
-            </a:outerShdw>
-          </a:effectLst>
         </p:spPr>
         <p:style>
           <a:lnRef idx="1">
@@ -10089,19 +11411,27 @@
           <a:lstStyle/>
           <a:p>
             <a:pPr algn="ctr"/>
-          </a:p>
-        </p:txBody>
-      </p:sp>
-      <p:sp>
-        <p:nvSpPr>
-          <p:cNvPr id="15" name="TextBox 14"/>
+            <a:r>
+              <a:rPr sz="3000">
+                <a:solidFill>
+                  <a:srgbClr val="463A32"/>
+                </a:solidFill>
+              </a:rPr>
+              <a:t>⚠️</a:t>
+            </a:r>
+          </a:p>
+        </p:txBody>
+      </p:sp>
+      <p:sp>
+        <p:nvSpPr>
+          <p:cNvPr id="12" name="TextBox 11"/>
           <p:cNvSpPr txBox="1"/>
           <p:nvPr/>
         </p:nvSpPr>
         <p:spPr>
           <a:xfrm>
-            <a:off x="8238744" y="1920240"/>
-            <a:ext cx="3017520" cy="731520"/>
+            <a:off x="8238744" y="2880360"/>
+            <a:ext cx="3017520" cy="2103120"/>
           </a:xfrm>
           <a:prstGeom prst="rect">
             <a:avLst/>
@@ -10121,21 +11451,43 @@
                   <a:srgbClr val="8F5A44"/>
                 </a:solidFill>
               </a:rPr>
-              <a:t>Sin carro propio</a:t>
-            </a:r>
-          </a:p>
-        </p:txBody>
-      </p:sp>
-      <p:sp>
-        <p:nvSpPr>
-          <p:cNvPr id="16" name="TextBox 15"/>
+              <a:t>Mostrador = ojo</a:t>
+            </a:r>
+          </a:p>
+          <a:p>
+            <a:pPr algn="ctr"/>
+            <a:r>
+              <a:rPr sz="600" b="0">
+                <a:solidFill>
+                  <a:srgbClr val="463A32"/>
+                </a:solidFill>
+              </a:rPr>
+              <a:t/>
+            </a:r>
+          </a:p>
+          <a:p>
+            <a:pPr algn="ctr"/>
+            <a:r>
+              <a:rPr sz="1350" b="0">
+                <a:solidFill>
+                  <a:srgbClr val="463A32"/>
+                </a:solidFill>
+              </a:rPr>
+              <a:t>Alamo / Localiza: más baratos, pero cierran ~10 pm. Reservar fuera de horario (24 h).</a:t>
+            </a:r>
+          </a:p>
+        </p:txBody>
+      </p:sp>
+      <p:sp>
+        <p:nvSpPr>
+          <p:cNvPr id="13" name="TextBox 12"/>
           <p:cNvSpPr txBox="1"/>
           <p:nvPr/>
         </p:nvSpPr>
         <p:spPr>
           <a:xfrm>
-            <a:off x="8238744" y="2743200"/>
-            <a:ext cx="3017520" cy="1005840"/>
+            <a:off x="548640" y="5303520"/>
+            <a:ext cx="11064240" cy="548640"/>
           </a:xfrm>
           <a:prstGeom prst="rect">
             <a:avLst/>
@@ -10150,57 +11502,12 @@
           <a:p>
             <a:pPr algn="ctr"/>
             <a:r>
-              <a:rPr sz="3400" b="1">
-                <a:solidFill>
-                  <a:srgbClr val="D9A75E"/>
-                </a:solidFill>
-              </a:rPr>
-              <a:t>$125.000</a:t>
-            </a:r>
-          </a:p>
-          <a:p>
-            <a:pPr algn="ctr"/>
-            <a:r>
               <a:rPr sz="1300" b="0">
                 <a:solidFill>
                   <a:srgbClr val="8A7A6E"/>
                 </a:solidFill>
               </a:rPr>
-              <a:t>por persona</a:t>
-            </a:r>
-          </a:p>
-        </p:txBody>
-      </p:sp>
-      <p:sp>
-        <p:nvSpPr>
-          <p:cNvPr id="17" name="TextBox 16"/>
-          <p:cNvSpPr txBox="1"/>
-          <p:nvPr/>
-        </p:nvSpPr>
-        <p:spPr>
-          <a:xfrm>
-            <a:off x="8284464" y="4069080"/>
-            <a:ext cx="2926080" cy="1463040"/>
-          </a:xfrm>
-          <a:prstGeom prst="rect">
-            <a:avLst/>
-          </a:prstGeom>
-          <a:noFill/>
-        </p:spPr>
-        <p:txBody>
-          <a:bodyPr wrap="square" anchor="t">
-            <a:spAutoFit/>
-          </a:bodyPr>
-          <a:lstStyle/>
-          <a:p>
-            <a:pPr algn="ctr"/>
-            <a:r>
-              <a:rPr sz="1350" b="0">
-                <a:solidFill>
-                  <a:srgbClr val="463A32"/>
-                </a:solidFill>
-              </a:rPr>
-              <a:t>Lo más barato: taxis + una van con conductor para el paseo.</a:t>
+              <a:t>Red de seguridad: los taxis oficiales del aeropuerto operan 24/7 (distintivo amarillo, tarifados).</a:t>
             </a:r>
           </a:p>
         </p:txBody>
@@ -10312,21 +11619,154 @@
                   <a:srgbClr val="FFFFFF"/>
                 </a:solidFill>
               </a:rPr>
-              <a:t>🚙   Opciones de vehículo (7 puestos)</a:t>
-            </a:r>
-          </a:p>
-        </p:txBody>
-      </p:sp>
-      <p:sp>
-        <p:nvSpPr>
-          <p:cNvPr id="4" name="TextBox 3"/>
+              <a:t>🚗   Cómo moverse — tres opciones</a:t>
+            </a:r>
+          </a:p>
+        </p:txBody>
+      </p:sp>
+      <p:sp>
+        <p:nvSpPr>
+          <p:cNvPr id="4" name="Rounded Rectangle 3"/>
+          <p:cNvSpPr/>
+          <p:nvPr/>
+        </p:nvSpPr>
+        <p:spPr>
+          <a:xfrm>
+            <a:off x="502920" y="1554480"/>
+            <a:ext cx="3566160" cy="4114800"/>
+          </a:xfrm>
+          <a:prstGeom prst="roundRect">
+            <a:avLst>
+              <a:gd name="adj" fmla="val 12000"/>
+            </a:avLst>
+          </a:prstGeom>
+          <a:solidFill>
+            <a:srgbClr val="F0E0C6"/>
+          </a:solidFill>
+          <a:ln w="25400">
+            <a:solidFill>
+              <a:srgbClr val="D9A75E"/>
+            </a:solidFill>
+          </a:ln>
+          <a:effectLst>
+            <a:outerShdw blurRad="95000" dist="40000" dir="5400000" rotWithShape="0">
+              <a:srgbClr val="6E5B4E">
+                <a:alpha val="32000"/>
+              </a:srgbClr>
+            </a:outerShdw>
+          </a:effectLst>
+        </p:spPr>
+        <p:style>
+          <a:lnRef idx="1">
+            <a:schemeClr val="accent1"/>
+          </a:lnRef>
+          <a:fillRef idx="3">
+            <a:schemeClr val="accent1"/>
+          </a:fillRef>
+          <a:effectRef idx="2">
+            <a:schemeClr val="accent1"/>
+          </a:effectRef>
+          <a:fontRef idx="minor">
+            <a:schemeClr val="lt1"/>
+          </a:fontRef>
+        </p:style>
+        <p:txBody>
+          <a:bodyPr rtlCol="0" anchor="ctr"/>
+          <a:lstStyle/>
+          <a:p>
+            <a:pPr algn="ctr"/>
+          </a:p>
+        </p:txBody>
+      </p:sp>
+      <p:sp>
+        <p:nvSpPr>
+          <p:cNvPr id="5" name="Rounded Rectangle 4"/>
+          <p:cNvSpPr/>
+          <p:nvPr/>
+        </p:nvSpPr>
+        <p:spPr>
+          <a:xfrm>
+            <a:off x="1508760" y="1325880"/>
+            <a:ext cx="1554480" cy="457200"/>
+          </a:xfrm>
+          <a:prstGeom prst="roundRect">
+            <a:avLst>
+              <a:gd name="adj" fmla="val 50000"/>
+            </a:avLst>
+          </a:prstGeom>
+          <a:solidFill>
+            <a:srgbClr val="D9A75E"/>
+          </a:solidFill>
+          <a:ln>
+            <a:noFill/>
+          </a:ln>
+        </p:spPr>
+        <p:style>
+          <a:lnRef idx="1">
+            <a:schemeClr val="accent1"/>
+          </a:lnRef>
+          <a:fillRef idx="3">
+            <a:schemeClr val="accent1"/>
+          </a:fillRef>
+          <a:effectRef idx="2">
+            <a:schemeClr val="accent1"/>
+          </a:effectRef>
+          <a:fontRef idx="minor">
+            <a:schemeClr val="lt1"/>
+          </a:fontRef>
+        </p:style>
+        <p:txBody>
+          <a:bodyPr rtlCol="0" anchor="ctr"/>
+          <a:lstStyle/>
+          <a:p>
+            <a:pPr algn="ctr"/>
+          </a:p>
+        </p:txBody>
+      </p:sp>
+      <p:sp>
+        <p:nvSpPr>
+          <p:cNvPr id="6" name="TextBox 5"/>
           <p:cNvSpPr txBox="1"/>
           <p:nvPr/>
         </p:nvSpPr>
         <p:spPr>
           <a:xfrm>
-            <a:off x="548640" y="1097280"/>
-            <a:ext cx="11064240" cy="502920"/>
+            <a:off x="1508760" y="1325880"/>
+            <a:ext cx="1554480" cy="457200"/>
+          </a:xfrm>
+          <a:prstGeom prst="rect">
+            <a:avLst/>
+          </a:prstGeom>
+          <a:noFill/>
+        </p:spPr>
+        <p:txBody>
+          <a:bodyPr wrap="square" anchor="ctr">
+            <a:spAutoFit/>
+          </a:bodyPr>
+          <a:lstStyle/>
+          <a:p>
+            <a:pPr algn="ctr"/>
+            <a:r>
+              <a:rPr sz="1200" b="1">
+                <a:solidFill>
+                  <a:srgbClr val="463A32"/>
+                </a:solidFill>
+              </a:rPr>
+              <a:t>★ Recomendado</a:t>
+            </a:r>
+          </a:p>
+        </p:txBody>
+      </p:sp>
+      <p:sp>
+        <p:nvSpPr>
+          <p:cNvPr id="7" name="TextBox 6"/>
+          <p:cNvSpPr txBox="1"/>
+          <p:nvPr/>
+        </p:nvSpPr>
+        <p:spPr>
+          <a:xfrm>
+            <a:off x="777240" y="1920240"/>
+            <a:ext cx="3017520" cy="731520"/>
           </a:xfrm>
           <a:prstGeom prst="rect">
             <a:avLst/>
@@ -10339,972 +11779,28 @@
           </a:bodyPr>
           <a:lstStyle/>
           <a:p>
-            <a:pPr algn="l"/>
-            <a:r>
-              <a:rPr sz="1300" b="0">
-                <a:solidFill>
-                  <a:srgbClr val="463A32"/>
-                </a:solidFill>
-              </a:rPr>
-              <a:t>Lo que cambia según dónde se recoja: local (entrega, cuadra con la llegada) vs mostrador (más barato, horario rígido).</a:t>
-            </a:r>
-          </a:p>
-        </p:txBody>
-      </p:sp>
-      <p:graphicFrame>
-        <p:nvGraphicFramePr>
-          <p:cNvPr id="5" name="Table 4"/>
-          <p:cNvGraphicFramePr>
-            <a:graphicFrameLocks noGrp="1"/>
-          </p:cNvGraphicFramePr>
-          <p:nvPr/>
-        </p:nvGraphicFramePr>
-        <p:xfrm>
-          <a:off x="365760" y="1691640"/>
-          <a:ext cx="11430000" cy="3657600"/>
-        </p:xfrm>
-        <a:graphic>
-          <a:graphicData uri="http://schemas.openxmlformats.org/drawingml/2006/table">
-            <a:tbl>
-              <a:tblPr firstRow="1" bandRow="1">
-                <a:tableStyleId>{5C22544A-7EE6-4342-B048-85BDC9FD1C3A}</a:tableStyleId>
-              </a:tblPr>
-              <a:tblGrid>
-                <a:gridCol w="2468880"/>
-                <a:gridCol w="1965960"/>
-                <a:gridCol w="1828800"/>
-                <a:gridCol w="1600200"/>
-                <a:gridCol w="2834640"/>
-                <a:gridCol w="731520"/>
-              </a:tblGrid>
-              <a:tr h="522514">
-                <a:tc>
-                  <a:txBody>
-                    <a:bodyPr/>
-                    <a:lstStyle/>
-                    <a:p>
-                      <a:r>
-                        <a:rPr b="1" sz="1100">
-                          <a:solidFill>
-                            <a:srgbClr val="FFFFFF"/>
-                          </a:solidFill>
-                        </a:rPr>
-                        <a:t>Vehículo (7 puestos)</a:t>
-                      </a:r>
-                    </a:p>
-                  </a:txBody>
-                  <a:tcPr>
-                    <a:solidFill>
-                      <a:srgbClr val="B5765C"/>
-                    </a:solidFill>
-                  </a:tcPr>
-                </a:tc>
-                <a:tc>
-                  <a:txBody>
-                    <a:bodyPr/>
-                    <a:lstStyle/>
-                    <a:p>
-                      <a:r>
-                        <a:rPr b="1" sz="1100">
-                          <a:solidFill>
-                            <a:srgbClr val="FFFFFF"/>
-                          </a:solidFill>
-                        </a:rPr>
-                        <a:t>Agencia</a:t>
-                      </a:r>
-                    </a:p>
-                  </a:txBody>
-                  <a:tcPr>
-                    <a:solidFill>
-                      <a:srgbClr val="B5765C"/>
-                    </a:solidFill>
-                  </a:tcPr>
-                </a:tc>
-                <a:tc>
-                  <a:txBody>
-                    <a:bodyPr/>
-                    <a:lstStyle/>
-                    <a:p>
-                      <a:r>
-                        <a:rPr b="1" sz="1100">
-                          <a:solidFill>
-                            <a:srgbClr val="FFFFFF"/>
-                          </a:solidFill>
-                        </a:rPr>
-                        <a:t>Tarifa (3 días)</a:t>
-                      </a:r>
-                    </a:p>
-                  </a:txBody>
-                  <a:tcPr>
-                    <a:solidFill>
-                      <a:srgbClr val="B5765C"/>
-                    </a:solidFill>
-                  </a:tcPr>
-                </a:tc>
-                <a:tc>
-                  <a:txBody>
-                    <a:bodyPr/>
-                    <a:lstStyle/>
-                    <a:p>
-                      <a:r>
-                        <a:rPr b="1" sz="1100">
-                          <a:solidFill>
-                            <a:srgbClr val="FFFFFF"/>
-                          </a:solidFill>
-                        </a:rPr>
-                        <a:t>Por persona</a:t>
-                      </a:r>
-                    </a:p>
-                  </a:txBody>
-                  <a:tcPr>
-                    <a:solidFill>
-                      <a:srgbClr val="B5765C"/>
-                    </a:solidFill>
-                  </a:tcPr>
-                </a:tc>
-                <a:tc>
-                  <a:txBody>
-                    <a:bodyPr/>
-                    <a:lstStyle/>
-                    <a:p>
-                      <a:r>
-                        <a:rPr b="1" sz="1100">
-                          <a:solidFill>
-                            <a:srgbClr val="FFFFFF"/>
-                          </a:solidFill>
-                        </a:rPr>
-                        <a:t>¿Cuadra con la llegada?</a:t>
-                      </a:r>
-                    </a:p>
-                  </a:txBody>
-                  <a:tcPr>
-                    <a:solidFill>
-                      <a:srgbClr val="B5765C"/>
-                    </a:solidFill>
-                  </a:tcPr>
-                </a:tc>
-                <a:tc>
-                  <a:txBody>
-                    <a:bodyPr/>
-                    <a:lstStyle/>
-                    <a:p>
-                      <a:r>
-                        <a:rPr b="1" sz="1100">
-                          <a:solidFill>
-                            <a:srgbClr val="FFFFFF"/>
-                          </a:solidFill>
-                        </a:rPr>
-                        <a:t>Ver</a:t>
-                      </a:r>
-                    </a:p>
-                  </a:txBody>
-                  <a:tcPr>
-                    <a:solidFill>
-                      <a:srgbClr val="B5765C"/>
-                    </a:solidFill>
-                  </a:tcPr>
-                </a:tc>
-              </a:tr>
-              <a:tr h="522514">
-                <a:tc>
-                  <a:txBody>
-                    <a:bodyPr/>
-                    <a:lstStyle/>
-                    <a:p>
-                      <a:r>
-                        <a:rPr sz="1050">
-                          <a:solidFill>
-                            <a:srgbClr val="463A32"/>
-                          </a:solidFill>
-                        </a:rPr>
-                        <a:t>Chevrolet Captiva Turbo</a:t>
-                      </a:r>
-                    </a:p>
-                  </a:txBody>
-                  <a:tcPr>
-                    <a:solidFill>
-                      <a:srgbClr val="F0E0C6"/>
-                    </a:solidFill>
-                  </a:tcPr>
-                </a:tc>
-                <a:tc>
-                  <a:txBody>
-                    <a:bodyPr/>
-                    <a:lstStyle/>
-                    <a:p>
-                      <a:r>
-                        <a:rPr sz="1050">
-                          <a:solidFill>
-                            <a:srgbClr val="463A32"/>
-                          </a:solidFill>
-                        </a:rPr>
-                        <a:t>Farallones (local)</a:t>
-                      </a:r>
-                    </a:p>
-                  </a:txBody>
-                  <a:tcPr>
-                    <a:solidFill>
-                      <a:srgbClr val="F0E0C6"/>
-                    </a:solidFill>
-                  </a:tcPr>
-                </a:tc>
-                <a:tc>
-                  <a:txBody>
-                    <a:bodyPr/>
-                    <a:lstStyle/>
-                    <a:p>
-                      <a:r>
-                        <a:rPr sz="1050">
-                          <a:solidFill>
-                            <a:srgbClr val="463A32"/>
-                          </a:solidFill>
-                        </a:rPr>
-                        <a:t>~$1.200.000</a:t>
-                      </a:r>
-                    </a:p>
-                  </a:txBody>
-                  <a:tcPr>
-                    <a:solidFill>
-                      <a:srgbClr val="F0E0C6"/>
-                    </a:solidFill>
-                  </a:tcPr>
-                </a:tc>
-                <a:tc>
-                  <a:txBody>
-                    <a:bodyPr/>
-                    <a:lstStyle/>
-                    <a:p>
-                      <a:pPr algn="ctr"/>
-                      <a:r>
-                        <a:rPr sz="1050">
-                          <a:solidFill>
-                            <a:srgbClr val="463A32"/>
-                          </a:solidFill>
-                        </a:rPr>
-                        <a:t>$171.429</a:t>
-                      </a:r>
-                    </a:p>
-                  </a:txBody>
-                  <a:tcPr>
-                    <a:solidFill>
-                      <a:srgbClr val="F0E0C6"/>
-                    </a:solidFill>
-                  </a:tcPr>
-                </a:tc>
-                <a:tc>
-                  <a:txBody>
-                    <a:bodyPr/>
-                    <a:lstStyle/>
-                    <a:p>
-                      <a:r>
-                        <a:rPr sz="1050">
-                          <a:solidFill>
-                            <a:srgbClr val="463A32"/>
-                          </a:solidFill>
-                        </a:rPr>
-                        <a:t>Sí — oficina en el aeropuerto y domicilio</a:t>
-                      </a:r>
-                    </a:p>
-                  </a:txBody>
-                  <a:tcPr>
-                    <a:solidFill>
-                      <a:srgbClr val="F0E0C6"/>
-                    </a:solidFill>
-                  </a:tcPr>
-                </a:tc>
-                <a:tc>
-                  <a:txBody>
-                    <a:bodyPr/>
-                    <a:lstStyle/>
-                    <a:p>
-                      <a:pPr algn="ctr"/>
-                      <a:r>
-                        <a:rPr sz="1050" u="sng">
-                          <a:solidFill>
-                            <a:srgbClr val="8F5A44"/>
-                          </a:solidFill>
-                          <a:hlinkClick r:id="rId2"/>
-                        </a:rPr>
-                        <a:t>ver</a:t>
-                      </a:r>
-                    </a:p>
-                  </a:txBody>
-                  <a:tcPr>
-                    <a:solidFill>
-                      <a:srgbClr val="F0E0C6"/>
-                    </a:solidFill>
-                  </a:tcPr>
-                </a:tc>
-              </a:tr>
-              <a:tr h="522514">
-                <a:tc>
-                  <a:txBody>
-                    <a:bodyPr/>
-                    <a:lstStyle/>
-                    <a:p>
-                      <a:r>
-                        <a:rPr sz="1050">
-                          <a:solidFill>
-                            <a:srgbClr val="463A32"/>
-                          </a:solidFill>
-                        </a:rPr>
-                        <a:t>Toyota Fortuner</a:t>
-                      </a:r>
-                    </a:p>
-                  </a:txBody>
-                  <a:tcPr>
-                    <a:solidFill>
-                      <a:srgbClr val="F0E0C6"/>
-                    </a:solidFill>
-                  </a:tcPr>
-                </a:tc>
-                <a:tc>
-                  <a:txBody>
-                    <a:bodyPr/>
-                    <a:lstStyle/>
-                    <a:p>
-                      <a:r>
-                        <a:rPr sz="1050">
-                          <a:solidFill>
-                            <a:srgbClr val="463A32"/>
-                          </a:solidFill>
-                        </a:rPr>
-                        <a:t>Farallones (local)</a:t>
-                      </a:r>
-                    </a:p>
-                  </a:txBody>
-                  <a:tcPr>
-                    <a:solidFill>
-                      <a:srgbClr val="F0E0C6"/>
-                    </a:solidFill>
-                  </a:tcPr>
-                </a:tc>
-                <a:tc>
-                  <a:txBody>
-                    <a:bodyPr/>
-                    <a:lstStyle/>
-                    <a:p>
-                      <a:r>
-                        <a:rPr sz="1050">
-                          <a:solidFill>
-                            <a:srgbClr val="463A32"/>
-                          </a:solidFill>
-                        </a:rPr>
-                        <a:t>desde $1.140.000</a:t>
-                      </a:r>
-                    </a:p>
-                  </a:txBody>
-                  <a:tcPr>
-                    <a:solidFill>
-                      <a:srgbClr val="F0E0C6"/>
-                    </a:solidFill>
-                  </a:tcPr>
-                </a:tc>
-                <a:tc>
-                  <a:txBody>
-                    <a:bodyPr/>
-                    <a:lstStyle/>
-                    <a:p>
-                      <a:pPr algn="ctr"/>
-                      <a:r>
-                        <a:rPr sz="1050">
-                          <a:solidFill>
-                            <a:srgbClr val="463A32"/>
-                          </a:solidFill>
-                        </a:rPr>
-                        <a:t>$162.857</a:t>
-                      </a:r>
-                    </a:p>
-                  </a:txBody>
-                  <a:tcPr>
-                    <a:solidFill>
-                      <a:srgbClr val="F0E0C6"/>
-                    </a:solidFill>
-                  </a:tcPr>
-                </a:tc>
-                <a:tc>
-                  <a:txBody>
-                    <a:bodyPr/>
-                    <a:lstStyle/>
-                    <a:p>
-                      <a:r>
-                        <a:rPr sz="1050">
-                          <a:solidFill>
-                            <a:srgbClr val="463A32"/>
-                          </a:solidFill>
-                        </a:rPr>
-                        <a:t>Sí — entrega coordinando el vuelo</a:t>
-                      </a:r>
-                    </a:p>
-                  </a:txBody>
-                  <a:tcPr>
-                    <a:solidFill>
-                      <a:srgbClr val="F0E0C6"/>
-                    </a:solidFill>
-                  </a:tcPr>
-                </a:tc>
-                <a:tc>
-                  <a:txBody>
-                    <a:bodyPr/>
-                    <a:lstStyle/>
-                    <a:p>
-                      <a:pPr algn="ctr"/>
-                      <a:r>
-                        <a:rPr sz="1050" u="sng">
-                          <a:solidFill>
-                            <a:srgbClr val="8F5A44"/>
-                          </a:solidFill>
-                          <a:hlinkClick r:id="rId3"/>
-                        </a:rPr>
-                        <a:t>ver</a:t>
-                      </a:r>
-                    </a:p>
-                  </a:txBody>
-                  <a:tcPr>
-                    <a:solidFill>
-                      <a:srgbClr val="F0E0C6"/>
-                    </a:solidFill>
-                  </a:tcPr>
-                </a:tc>
-              </a:tr>
-              <a:tr h="522514">
-                <a:tc>
-                  <a:txBody>
-                    <a:bodyPr/>
-                    <a:lstStyle/>
-                    <a:p>
-                      <a:r>
-                        <a:rPr sz="1050">
-                          <a:solidFill>
-                            <a:srgbClr val="463A32"/>
-                          </a:solidFill>
-                        </a:rPr>
-                        <a:t>Mitsubishi Montero Sport</a:t>
-                      </a:r>
-                    </a:p>
-                  </a:txBody>
-                  <a:tcPr>
-                    <a:solidFill>
-                      <a:srgbClr val="F0E0C6"/>
-                    </a:solidFill>
-                  </a:tcPr>
-                </a:tc>
-                <a:tc>
-                  <a:txBody>
-                    <a:bodyPr/>
-                    <a:lstStyle/>
-                    <a:p>
-                      <a:r>
-                        <a:rPr sz="1050">
-                          <a:solidFill>
-                            <a:srgbClr val="463A32"/>
-                          </a:solidFill>
-                        </a:rPr>
-                        <a:t>Farallones (local)</a:t>
-                      </a:r>
-                    </a:p>
-                  </a:txBody>
-                  <a:tcPr>
-                    <a:solidFill>
-                      <a:srgbClr val="F0E0C6"/>
-                    </a:solidFill>
-                  </a:tcPr>
-                </a:tc>
-                <a:tc>
-                  <a:txBody>
-                    <a:bodyPr/>
-                    <a:lstStyle/>
-                    <a:p>
-                      <a:r>
-                        <a:rPr sz="1050">
-                          <a:solidFill>
-                            <a:srgbClr val="463A32"/>
-                          </a:solidFill>
-                        </a:rPr>
-                        <a:t>desde $705.000</a:t>
-                      </a:r>
-                    </a:p>
-                  </a:txBody>
-                  <a:tcPr>
-                    <a:solidFill>
-                      <a:srgbClr val="F0E0C6"/>
-                    </a:solidFill>
-                  </a:tcPr>
-                </a:tc>
-                <a:tc>
-                  <a:txBody>
-                    <a:bodyPr/>
-                    <a:lstStyle/>
-                    <a:p>
-                      <a:pPr algn="ctr"/>
-                      <a:r>
-                        <a:rPr sz="1050">
-                          <a:solidFill>
-                            <a:srgbClr val="463A32"/>
-                          </a:solidFill>
-                        </a:rPr>
-                        <a:t>$100.714</a:t>
-                      </a:r>
-                    </a:p>
-                  </a:txBody>
-                  <a:tcPr>
-                    <a:solidFill>
-                      <a:srgbClr val="F0E0C6"/>
-                    </a:solidFill>
-                  </a:tcPr>
-                </a:tc>
-                <a:tc>
-                  <a:txBody>
-                    <a:bodyPr/>
-                    <a:lstStyle/>
-                    <a:p>
-                      <a:r>
-                        <a:rPr sz="1050">
-                          <a:solidFill>
-                            <a:srgbClr val="463A32"/>
-                          </a:solidFill>
-                        </a:rPr>
-                        <a:t>Sí — entrega coordinando el vuelo</a:t>
-                      </a:r>
-                    </a:p>
-                  </a:txBody>
-                  <a:tcPr>
-                    <a:solidFill>
-                      <a:srgbClr val="F0E0C6"/>
-                    </a:solidFill>
-                  </a:tcPr>
-                </a:tc>
-                <a:tc>
-                  <a:txBody>
-                    <a:bodyPr/>
-                    <a:lstStyle/>
-                    <a:p>
-                      <a:pPr algn="ctr"/>
-                      <a:r>
-                        <a:rPr sz="1050" u="sng">
-                          <a:solidFill>
-                            <a:srgbClr val="8F5A44"/>
-                          </a:solidFill>
-                          <a:hlinkClick r:id="rId3"/>
-                        </a:rPr>
-                        <a:t>ver</a:t>
-                      </a:r>
-                    </a:p>
-                  </a:txBody>
-                  <a:tcPr>
-                    <a:solidFill>
-                      <a:srgbClr val="F0E0C6"/>
-                    </a:solidFill>
-                  </a:tcPr>
-                </a:tc>
-              </a:tr>
-              <a:tr h="522514">
-                <a:tc>
-                  <a:txBody>
-                    <a:bodyPr/>
-                    <a:lstStyle/>
-                    <a:p>
-                      <a:r>
-                        <a:rPr sz="1050">
-                          <a:solidFill>
-                            <a:srgbClr val="463A32"/>
-                          </a:solidFill>
-                        </a:rPr>
-                        <a:t>7 puestos (varios modelos)</a:t>
-                      </a:r>
-                    </a:p>
-                  </a:txBody>
-                  <a:tcPr>
-                    <a:solidFill>
-                      <a:srgbClr val="F0E0C6"/>
-                    </a:solidFill>
-                  </a:tcPr>
-                </a:tc>
-                <a:tc>
-                  <a:txBody>
-                    <a:bodyPr/>
-                    <a:lstStyle/>
-                    <a:p>
-                      <a:r>
-                        <a:rPr sz="1050">
-                          <a:solidFill>
-                            <a:srgbClr val="463A32"/>
-                          </a:solidFill>
-                        </a:rPr>
-                        <a:t>WayCarCali (local)</a:t>
-                      </a:r>
-                    </a:p>
-                  </a:txBody>
-                  <a:tcPr>
-                    <a:solidFill>
-                      <a:srgbClr val="F0E0C6"/>
-                    </a:solidFill>
-                  </a:tcPr>
-                </a:tc>
-                <a:tc>
-                  <a:txBody>
-                    <a:bodyPr/>
-                    <a:lstStyle/>
-                    <a:p>
-                      <a:r>
-                        <a:rPr sz="1050">
-                          <a:solidFill>
-                            <a:srgbClr val="463A32"/>
-                          </a:solidFill>
-                        </a:rPr>
-                        <a:t>desde $360.000</a:t>
-                      </a:r>
-                    </a:p>
-                  </a:txBody>
-                  <a:tcPr>
-                    <a:solidFill>
-                      <a:srgbClr val="F0E0C6"/>
-                    </a:solidFill>
-                  </a:tcPr>
-                </a:tc>
-                <a:tc>
-                  <a:txBody>
-                    <a:bodyPr/>
-                    <a:lstStyle/>
-                    <a:p>
-                      <a:pPr algn="ctr"/>
-                      <a:r>
-                        <a:rPr sz="1050">
-                          <a:solidFill>
-                            <a:srgbClr val="463A32"/>
-                          </a:solidFill>
-                        </a:rPr>
-                        <a:t>$51.429</a:t>
-                      </a:r>
-                    </a:p>
-                  </a:txBody>
-                  <a:tcPr>
-                    <a:solidFill>
-                      <a:srgbClr val="F0E0C6"/>
-                    </a:solidFill>
-                  </a:tcPr>
-                </a:tc>
-                <a:tc>
-                  <a:txBody>
-                    <a:bodyPr/>
-                    <a:lstStyle/>
-                    <a:p>
-                      <a:r>
-                        <a:rPr sz="1050">
-                          <a:solidFill>
-                            <a:srgbClr val="463A32"/>
-                          </a:solidFill>
-                        </a:rPr>
-                        <a:t>Sí — domicilio gratis al aeropuerto (3+ días)</a:t>
-                      </a:r>
-                    </a:p>
-                  </a:txBody>
-                  <a:tcPr>
-                    <a:solidFill>
-                      <a:srgbClr val="F0E0C6"/>
-                    </a:solidFill>
-                  </a:tcPr>
-                </a:tc>
-                <a:tc>
-                  <a:txBody>
-                    <a:bodyPr/>
-                    <a:lstStyle/>
-                    <a:p>
-                      <a:pPr algn="ctr"/>
-                      <a:r>
-                        <a:rPr sz="1050" u="sng">
-                          <a:solidFill>
-                            <a:srgbClr val="8F5A44"/>
-                          </a:solidFill>
-                          <a:hlinkClick r:id="rId4"/>
-                        </a:rPr>
-                        <a:t>ver</a:t>
-                      </a:r>
-                    </a:p>
-                  </a:txBody>
-                  <a:tcPr>
-                    <a:solidFill>
-                      <a:srgbClr val="F0E0C6"/>
-                    </a:solidFill>
-                  </a:tcPr>
-                </a:tc>
-              </a:tr>
-              <a:tr h="522514">
-                <a:tc>
-                  <a:txBody>
-                    <a:bodyPr/>
-                    <a:lstStyle/>
-                    <a:p>
-                      <a:r>
-                        <a:rPr sz="1050">
-                          <a:solidFill>
-                            <a:srgbClr val="463A32"/>
-                          </a:solidFill>
-                        </a:rPr>
-                        <a:t>Nissan X-Trail</a:t>
-                      </a:r>
-                    </a:p>
-                  </a:txBody>
-                  <a:tcPr>
-                    <a:solidFill>
-                      <a:srgbClr val="EFE6DA"/>
-                    </a:solidFill>
-                  </a:tcPr>
-                </a:tc>
-                <a:tc>
-                  <a:txBody>
-                    <a:bodyPr/>
-                    <a:lstStyle/>
-                    <a:p>
-                      <a:r>
-                        <a:rPr sz="1050">
-                          <a:solidFill>
-                            <a:srgbClr val="463A32"/>
-                          </a:solidFill>
-                        </a:rPr>
-                        <a:t>Kayak · EconomyBookings</a:t>
-                      </a:r>
-                    </a:p>
-                  </a:txBody>
-                  <a:tcPr>
-                    <a:solidFill>
-                      <a:srgbClr val="EFE6DA"/>
-                    </a:solidFill>
-                  </a:tcPr>
-                </a:tc>
-                <a:tc>
-                  <a:txBody>
-                    <a:bodyPr/>
-                    <a:lstStyle/>
-                    <a:p>
-                      <a:r>
-                        <a:rPr sz="1050">
-                          <a:solidFill>
-                            <a:srgbClr val="463A32"/>
-                          </a:solidFill>
-                        </a:rPr>
-                        <a:t>$1.033.028</a:t>
-                      </a:r>
-                    </a:p>
-                  </a:txBody>
-                  <a:tcPr>
-                    <a:solidFill>
-                      <a:srgbClr val="EFE6DA"/>
-                    </a:solidFill>
-                  </a:tcPr>
-                </a:tc>
-                <a:tc>
-                  <a:txBody>
-                    <a:bodyPr/>
-                    <a:lstStyle/>
-                    <a:p>
-                      <a:pPr algn="ctr"/>
-                      <a:r>
-                        <a:rPr sz="1050">
-                          <a:solidFill>
-                            <a:srgbClr val="463A32"/>
-                          </a:solidFill>
-                        </a:rPr>
-                        <a:t>$147.575</a:t>
-                      </a:r>
-                    </a:p>
-                  </a:txBody>
-                  <a:tcPr>
-                    <a:solidFill>
-                      <a:srgbClr val="EFE6DA"/>
-                    </a:solidFill>
-                  </a:tcPr>
-                </a:tc>
-                <a:tc>
-                  <a:txBody>
-                    <a:bodyPr/>
-                    <a:lstStyle/>
-                    <a:p>
-                      <a:r>
-                        <a:rPr sz="1050">
-                          <a:solidFill>
-                            <a:srgbClr val="463A32"/>
-                          </a:solidFill>
-                        </a:rPr>
-                        <a:t>Mostrador: cierra ~10 pm</a:t>
-                      </a:r>
-                    </a:p>
-                  </a:txBody>
-                  <a:tcPr>
-                    <a:solidFill>
-                      <a:srgbClr val="EFE6DA"/>
-                    </a:solidFill>
-                  </a:tcPr>
-                </a:tc>
-                <a:tc>
-                  <a:txBody>
-                    <a:bodyPr/>
-                    <a:lstStyle/>
-                    <a:p>
-                      <a:pPr algn="ctr"/>
-                      <a:r>
-                        <a:rPr sz="1050" u="sng">
-                          <a:solidFill>
-                            <a:srgbClr val="8F5A44"/>
-                          </a:solidFill>
-                          <a:hlinkClick r:id="rId5"/>
-                        </a:rPr>
-                        <a:t>ver</a:t>
-                      </a:r>
-                    </a:p>
-                  </a:txBody>
-                  <a:tcPr>
-                    <a:solidFill>
-                      <a:srgbClr val="EFE6DA"/>
-                    </a:solidFill>
-                  </a:tcPr>
-                </a:tc>
-              </a:tr>
-              <a:tr h="522516">
-                <a:tc>
-                  <a:txBody>
-                    <a:bodyPr/>
-                    <a:lstStyle/>
-                    <a:p>
-                      <a:r>
-                        <a:rPr sz="1050">
-                          <a:solidFill>
-                            <a:srgbClr val="463A32"/>
-                          </a:solidFill>
-                        </a:rPr>
-                        <a:t>SUV mediano híbrido</a:t>
-                      </a:r>
-                    </a:p>
-                  </a:txBody>
-                  <a:tcPr>
-                    <a:solidFill>
-                      <a:srgbClr val="EFE6DA"/>
-                    </a:solidFill>
-                  </a:tcPr>
-                </a:tc>
-                <a:tc>
-                  <a:txBody>
-                    <a:bodyPr/>
-                    <a:lstStyle/>
-                    <a:p>
-                      <a:r>
-                        <a:rPr sz="1050">
-                          <a:solidFill>
-                            <a:srgbClr val="463A32"/>
-                          </a:solidFill>
-                        </a:rPr>
-                        <a:t>Kayak · Alkilautos</a:t>
-                      </a:r>
-                    </a:p>
-                  </a:txBody>
-                  <a:tcPr>
-                    <a:solidFill>
-                      <a:srgbClr val="EFE6DA"/>
-                    </a:solidFill>
-                  </a:tcPr>
-                </a:tc>
-                <a:tc>
-                  <a:txBody>
-                    <a:bodyPr/>
-                    <a:lstStyle/>
-                    <a:p>
-                      <a:r>
-                        <a:rPr sz="1050">
-                          <a:solidFill>
-                            <a:srgbClr val="463A32"/>
-                          </a:solidFill>
-                        </a:rPr>
-                        <a:t>$1.847.639</a:t>
-                      </a:r>
-                    </a:p>
-                  </a:txBody>
-                  <a:tcPr>
-                    <a:solidFill>
-                      <a:srgbClr val="EFE6DA"/>
-                    </a:solidFill>
-                  </a:tcPr>
-                </a:tc>
-                <a:tc>
-                  <a:txBody>
-                    <a:bodyPr/>
-                    <a:lstStyle/>
-                    <a:p>
-                      <a:pPr algn="ctr"/>
-                      <a:r>
-                        <a:rPr sz="1050">
-                          <a:solidFill>
-                            <a:srgbClr val="463A32"/>
-                          </a:solidFill>
-                        </a:rPr>
-                        <a:t>$263.948</a:t>
-                      </a:r>
-                    </a:p>
-                  </a:txBody>
-                  <a:tcPr>
-                    <a:solidFill>
-                      <a:srgbClr val="EFE6DA"/>
-                    </a:solidFill>
-                  </a:tcPr>
-                </a:tc>
-                <a:tc>
-                  <a:txBody>
-                    <a:bodyPr/>
-                    <a:lstStyle/>
-                    <a:p>
-                      <a:r>
-                        <a:rPr sz="1050">
-                          <a:solidFill>
-                            <a:srgbClr val="463A32"/>
-                          </a:solidFill>
-                        </a:rPr>
-                        <a:t>Mostrador: cierra ~10 pm</a:t>
-                      </a:r>
-                    </a:p>
-                  </a:txBody>
-                  <a:tcPr>
-                    <a:solidFill>
-                      <a:srgbClr val="EFE6DA"/>
-                    </a:solidFill>
-                  </a:tcPr>
-                </a:tc>
-                <a:tc>
-                  <a:txBody>
-                    <a:bodyPr/>
-                    <a:lstStyle/>
-                    <a:p>
-                      <a:pPr algn="ctr"/>
-                      <a:r>
-                        <a:rPr sz="1050" u="sng">
-                          <a:solidFill>
-                            <a:srgbClr val="8F5A44"/>
-                          </a:solidFill>
-                          <a:hlinkClick r:id="rId5"/>
-                        </a:rPr>
-                        <a:t>ver</a:t>
-                      </a:r>
-                    </a:p>
-                  </a:txBody>
-                  <a:tcPr>
-                    <a:solidFill>
-                      <a:srgbClr val="EFE6DA"/>
-                    </a:solidFill>
-                  </a:tcPr>
-                </a:tc>
-              </a:tr>
-            </a:tbl>
-          </a:graphicData>
-        </a:graphic>
-      </p:graphicFrame>
-      <p:sp>
-        <p:nvSpPr>
-          <p:cNvPr id="6" name="TextBox 5"/>
+            <a:pPr algn="ctr"/>
+            <a:r>
+              <a:rPr sz="1800" b="1">
+                <a:solidFill>
+                  <a:srgbClr val="8F5A44"/>
+                </a:solidFill>
+              </a:rPr>
+              <a:t>Carro local (entrega)</a:t>
+            </a:r>
+          </a:p>
+        </p:txBody>
+      </p:sp>
+      <p:sp>
+        <p:nvSpPr>
+          <p:cNvPr id="8" name="TextBox 7"/>
           <p:cNvSpPr txBox="1"/>
           <p:nvPr/>
         </p:nvSpPr>
         <p:spPr>
           <a:xfrm>
-            <a:off x="457200" y="5577840"/>
-            <a:ext cx="11338560" cy="1097280"/>
+            <a:off x="777240" y="2743200"/>
+            <a:ext cx="3017520" cy="1005840"/>
           </a:xfrm>
           <a:prstGeom prst="rect">
             <a:avLst/>
@@ -11317,14 +11813,389 @@
           </a:bodyPr>
           <a:lstStyle/>
           <a:p>
-            <a:pPr algn="l"/>
-            <a:r>
-              <a:rPr sz="1150" b="0">
+            <a:pPr algn="ctr"/>
+            <a:r>
+              <a:rPr sz="3400" b="1">
+                <a:solidFill>
+                  <a:srgbClr val="D9A75E"/>
+                </a:solidFill>
+              </a:rPr>
+              <a:t>$200.000</a:t>
+            </a:r>
+          </a:p>
+          <a:p>
+            <a:pPr algn="ctr"/>
+            <a:r>
+              <a:rPr sz="1300" b="0">
+                <a:solidFill>
+                  <a:srgbClr val="8A7A6E"/>
+                </a:solidFill>
+              </a:rPr>
+              <a:t>por persona</a:t>
+            </a:r>
+          </a:p>
+        </p:txBody>
+      </p:sp>
+      <p:sp>
+        <p:nvSpPr>
+          <p:cNvPr id="9" name="TextBox 8"/>
+          <p:cNvSpPr txBox="1"/>
+          <p:nvPr/>
+        </p:nvSpPr>
+        <p:spPr>
+          <a:xfrm>
+            <a:off x="822960" y="4069080"/>
+            <a:ext cx="2926080" cy="1463040"/>
+          </a:xfrm>
+          <a:prstGeom prst="rect">
+            <a:avLst/>
+          </a:prstGeom>
+          <a:noFill/>
+        </p:spPr>
+        <p:txBody>
+          <a:bodyPr wrap="square" anchor="t">
+            <a:spAutoFit/>
+          </a:bodyPr>
+          <a:lstStyle/>
+          <a:p>
+            <a:pPr algn="ctr"/>
+            <a:r>
+              <a:rPr sz="1350" b="0">
+                <a:solidFill>
+                  <a:srgbClr val="463A32"/>
+                </a:solidFill>
+              </a:rPr>
+              <a:t>Cuadra con la llegada de noche; libertad para salir de Cali.</a:t>
+            </a:r>
+          </a:p>
+        </p:txBody>
+      </p:sp>
+      <p:sp>
+        <p:nvSpPr>
+          <p:cNvPr id="10" name="Rounded Rectangle 9"/>
+          <p:cNvSpPr/>
+          <p:nvPr/>
+        </p:nvSpPr>
+        <p:spPr>
+          <a:xfrm>
+            <a:off x="4233672" y="1554480"/>
+            <a:ext cx="3566160" cy="4114800"/>
+          </a:xfrm>
+          <a:prstGeom prst="roundRect">
+            <a:avLst>
+              <a:gd name="adj" fmla="val 12000"/>
+            </a:avLst>
+          </a:prstGeom>
+          <a:solidFill>
+            <a:srgbClr val="FFFFFF"/>
+          </a:solidFill>
+          <a:ln>
+            <a:noFill/>
+          </a:ln>
+          <a:effectLst>
+            <a:outerShdw blurRad="95000" dist="40000" dir="5400000" rotWithShape="0">
+              <a:srgbClr val="6E5B4E">
+                <a:alpha val="32000"/>
+              </a:srgbClr>
+            </a:outerShdw>
+          </a:effectLst>
+        </p:spPr>
+        <p:style>
+          <a:lnRef idx="1">
+            <a:schemeClr val="accent1"/>
+          </a:lnRef>
+          <a:fillRef idx="3">
+            <a:schemeClr val="accent1"/>
+          </a:fillRef>
+          <a:effectRef idx="2">
+            <a:schemeClr val="accent1"/>
+          </a:effectRef>
+          <a:fontRef idx="minor">
+            <a:schemeClr val="lt1"/>
+          </a:fontRef>
+        </p:style>
+        <p:txBody>
+          <a:bodyPr rtlCol="0" anchor="ctr"/>
+          <a:lstStyle/>
+          <a:p>
+            <a:pPr algn="ctr"/>
+          </a:p>
+        </p:txBody>
+      </p:sp>
+      <p:sp>
+        <p:nvSpPr>
+          <p:cNvPr id="11" name="TextBox 10"/>
+          <p:cNvSpPr txBox="1"/>
+          <p:nvPr/>
+        </p:nvSpPr>
+        <p:spPr>
+          <a:xfrm>
+            <a:off x="4507992" y="1920240"/>
+            <a:ext cx="3017520" cy="731520"/>
+          </a:xfrm>
+          <a:prstGeom prst="rect">
+            <a:avLst/>
+          </a:prstGeom>
+          <a:noFill/>
+        </p:spPr>
+        <p:txBody>
+          <a:bodyPr wrap="square" anchor="t">
+            <a:spAutoFit/>
+          </a:bodyPr>
+          <a:lstStyle/>
+          <a:p>
+            <a:pPr algn="ctr"/>
+            <a:r>
+              <a:rPr sz="1800" b="1">
                 <a:solidFill>
                   <a:srgbClr val="8F5A44"/>
                 </a:solidFill>
               </a:rPr>
-              <a:t>Todos los precios son por los 3 días, solo el alquiler (sin gasolina ni parqueo). Las tarifas locales 'desde' se calculan sobre la tarifa base/día × 3; en alquiler corto el total real suele ser mayor (la Captiva, confirmada, cuesta ~$1.200.000) — pidan el exacto por WhatsApp. Lo clave sigue siendo el horario: las locales entregan coordinando el vuelo; los mostradores cierran ~10 pm.</a:t>
+              <a:t>Mostrador (Kayak)</a:t>
+            </a:r>
+          </a:p>
+        </p:txBody>
+      </p:sp>
+      <p:sp>
+        <p:nvSpPr>
+          <p:cNvPr id="12" name="TextBox 11"/>
+          <p:cNvSpPr txBox="1"/>
+          <p:nvPr/>
+        </p:nvSpPr>
+        <p:spPr>
+          <a:xfrm>
+            <a:off x="4507992" y="2743200"/>
+            <a:ext cx="3017520" cy="1005840"/>
+          </a:xfrm>
+          <a:prstGeom prst="rect">
+            <a:avLst/>
+          </a:prstGeom>
+          <a:noFill/>
+        </p:spPr>
+        <p:txBody>
+          <a:bodyPr wrap="square" anchor="t">
+            <a:spAutoFit/>
+          </a:bodyPr>
+          <a:lstStyle/>
+          <a:p>
+            <a:pPr algn="ctr"/>
+            <a:r>
+              <a:rPr sz="3400" b="1">
+                <a:solidFill>
+                  <a:srgbClr val="D9A75E"/>
+                </a:solidFill>
+              </a:rPr>
+              <a:t>$180.000</a:t>
+            </a:r>
+          </a:p>
+          <a:p>
+            <a:pPr algn="ctr"/>
+            <a:r>
+              <a:rPr sz="1300" b="0">
+                <a:solidFill>
+                  <a:srgbClr val="8A7A6E"/>
+                </a:solidFill>
+              </a:rPr>
+              <a:t>por persona</a:t>
+            </a:r>
+          </a:p>
+        </p:txBody>
+      </p:sp>
+      <p:sp>
+        <p:nvSpPr>
+          <p:cNvPr id="13" name="TextBox 12"/>
+          <p:cNvSpPr txBox="1"/>
+          <p:nvPr/>
+        </p:nvSpPr>
+        <p:spPr>
+          <a:xfrm>
+            <a:off x="4553712" y="4069080"/>
+            <a:ext cx="2926080" cy="1463040"/>
+          </a:xfrm>
+          <a:prstGeom prst="rect">
+            <a:avLst/>
+          </a:prstGeom>
+          <a:noFill/>
+        </p:spPr>
+        <p:txBody>
+          <a:bodyPr wrap="square" anchor="t">
+            <a:spAutoFit/>
+          </a:bodyPr>
+          <a:lstStyle/>
+          <a:p>
+            <a:pPr algn="ctr"/>
+            <a:r>
+              <a:rPr sz="1350" b="0">
+                <a:solidFill>
+                  <a:srgbClr val="463A32"/>
+                </a:solidFill>
+              </a:rPr>
+              <a:t>Más barato, pero el mostrador cierra ~10 pm.</a:t>
+            </a:r>
+          </a:p>
+        </p:txBody>
+      </p:sp>
+      <p:sp>
+        <p:nvSpPr>
+          <p:cNvPr id="14" name="Rounded Rectangle 13"/>
+          <p:cNvSpPr/>
+          <p:nvPr/>
+        </p:nvSpPr>
+        <p:spPr>
+          <a:xfrm>
+            <a:off x="7964424" y="1554480"/>
+            <a:ext cx="3566160" cy="4114800"/>
+          </a:xfrm>
+          <a:prstGeom prst="roundRect">
+            <a:avLst>
+              <a:gd name="adj" fmla="val 12000"/>
+            </a:avLst>
+          </a:prstGeom>
+          <a:solidFill>
+            <a:srgbClr val="FFFFFF"/>
+          </a:solidFill>
+          <a:ln>
+            <a:noFill/>
+          </a:ln>
+          <a:effectLst>
+            <a:outerShdw blurRad="95000" dist="40000" dir="5400000" rotWithShape="0">
+              <a:srgbClr val="6E5B4E">
+                <a:alpha val="32000"/>
+              </a:srgbClr>
+            </a:outerShdw>
+          </a:effectLst>
+        </p:spPr>
+        <p:style>
+          <a:lnRef idx="1">
+            <a:schemeClr val="accent1"/>
+          </a:lnRef>
+          <a:fillRef idx="3">
+            <a:schemeClr val="accent1"/>
+          </a:fillRef>
+          <a:effectRef idx="2">
+            <a:schemeClr val="accent1"/>
+          </a:effectRef>
+          <a:fontRef idx="minor">
+            <a:schemeClr val="lt1"/>
+          </a:fontRef>
+        </p:style>
+        <p:txBody>
+          <a:bodyPr rtlCol="0" anchor="ctr"/>
+          <a:lstStyle/>
+          <a:p>
+            <a:pPr algn="ctr"/>
+          </a:p>
+        </p:txBody>
+      </p:sp>
+      <p:sp>
+        <p:nvSpPr>
+          <p:cNvPr id="15" name="TextBox 14"/>
+          <p:cNvSpPr txBox="1"/>
+          <p:nvPr/>
+        </p:nvSpPr>
+        <p:spPr>
+          <a:xfrm>
+            <a:off x="8238744" y="1920240"/>
+            <a:ext cx="3017520" cy="731520"/>
+          </a:xfrm>
+          <a:prstGeom prst="rect">
+            <a:avLst/>
+          </a:prstGeom>
+          <a:noFill/>
+        </p:spPr>
+        <p:txBody>
+          <a:bodyPr wrap="square" anchor="t">
+            <a:spAutoFit/>
+          </a:bodyPr>
+          <a:lstStyle/>
+          <a:p>
+            <a:pPr algn="ctr"/>
+            <a:r>
+              <a:rPr sz="1800" b="1">
+                <a:solidFill>
+                  <a:srgbClr val="8F5A44"/>
+                </a:solidFill>
+              </a:rPr>
+              <a:t>Sin carro propio</a:t>
+            </a:r>
+          </a:p>
+        </p:txBody>
+      </p:sp>
+      <p:sp>
+        <p:nvSpPr>
+          <p:cNvPr id="16" name="TextBox 15"/>
+          <p:cNvSpPr txBox="1"/>
+          <p:nvPr/>
+        </p:nvSpPr>
+        <p:spPr>
+          <a:xfrm>
+            <a:off x="8238744" y="2743200"/>
+            <a:ext cx="3017520" cy="1005840"/>
+          </a:xfrm>
+          <a:prstGeom prst="rect">
+            <a:avLst/>
+          </a:prstGeom>
+          <a:noFill/>
+        </p:spPr>
+        <p:txBody>
+          <a:bodyPr wrap="square" anchor="t">
+            <a:spAutoFit/>
+          </a:bodyPr>
+          <a:lstStyle/>
+          <a:p>
+            <a:pPr algn="ctr"/>
+            <a:r>
+              <a:rPr sz="3400" b="1">
+                <a:solidFill>
+                  <a:srgbClr val="D9A75E"/>
+                </a:solidFill>
+              </a:rPr>
+              <a:t>$125.000</a:t>
+            </a:r>
+          </a:p>
+          <a:p>
+            <a:pPr algn="ctr"/>
+            <a:r>
+              <a:rPr sz="1300" b="0">
+                <a:solidFill>
+                  <a:srgbClr val="8A7A6E"/>
+                </a:solidFill>
+              </a:rPr>
+              <a:t>por persona</a:t>
+            </a:r>
+          </a:p>
+        </p:txBody>
+      </p:sp>
+      <p:sp>
+        <p:nvSpPr>
+          <p:cNvPr id="17" name="TextBox 16"/>
+          <p:cNvSpPr txBox="1"/>
+          <p:nvPr/>
+        </p:nvSpPr>
+        <p:spPr>
+          <a:xfrm>
+            <a:off x="8284464" y="4069080"/>
+            <a:ext cx="2926080" cy="1463040"/>
+          </a:xfrm>
+          <a:prstGeom prst="rect">
+            <a:avLst/>
+          </a:prstGeom>
+          <a:noFill/>
+        </p:spPr>
+        <p:txBody>
+          <a:bodyPr wrap="square" anchor="t">
+            <a:spAutoFit/>
+          </a:bodyPr>
+          <a:lstStyle/>
+          <a:p>
+            <a:pPr algn="ctr"/>
+            <a:r>
+              <a:rPr sz="1350" b="0">
+                <a:solidFill>
+                  <a:srgbClr val="463A32"/>
+                </a:solidFill>
+              </a:rPr>
+              <a:t>Lo más barato: taxis + una van con conductor para el paseo.</a:t>
             </a:r>
           </a:p>
         </p:txBody>

</xml_diff>

<commit_message>
Airbnb v5: saca Casa 7p (fea) y Refugio (dispo/cara), suma 2 del noroeste; ★ = mejor con cama
- El usuario descartó Casa 7p garaje (poco atractiva) y Refugio Vistas (noches no disponibles
  + cara). Van a descartes con su razón.
- Promovidas las dos mejores del noroeste que quedaban: Apto Granada/Chipichape (~1,8 km, la
  más céntrica y barata) y Torre Gardes (~3 km, piscina, 4 baños, 5.0). Set de 4.
- La ★ ya no es la de mayor puntaje sino la mejor CON cama para los 7 (camas>=5): La Flora
  (7 camas). La #1 por puntaje (Granada/Chipichape, 77.2) es más barata/céntrica pero 4 camas;
  se explica el matiz en informe/PDF/tarjeta del gráfico.
- Normalización de precio dentro del set, pero con 4 ítems (con 2 casi iguales se distorsionaba).
- Actualiza D-005 (v5).
</commit_message>
<xml_diff>
--- a/output/Mini-Boom-en-Cali_Presentacion.pptx
+++ b/output/Mini-Boom-en-Cali_Presentacion.pptx
@@ -325,7 +325,7 @@
             <c:idx val="0"/>
             <c:spPr>
               <a:solidFill>
-                <a:srgbClr val="D9A75E"/>
+                <a:srgbClr val="D8C4B2"/>
               </a:solidFill>
             </c:spPr>
           </c:dPt>
@@ -333,7 +333,7 @@
             <c:idx val="1"/>
             <c:spPr>
               <a:solidFill>
-                <a:srgbClr val="D8C4B2"/>
+                <a:srgbClr val="D9A75E"/>
               </a:solidFill>
             </c:spPr>
           </c:dPt>
@@ -359,16 +359,16 @@
               <c:strCache>
                 <c:ptCount val="4"/>
                 <c:pt idx="0">
-                  <c:v>Apto La Flora (7 camas)</c:v>
+                  <c:v>Apto Granada/Chipichape</c:v>
                 </c:pt>
                 <c:pt idx="1">
-                  <c:v>Casa 7p garaje</c:v>
+                  <c:v>Apto La Flora (7 camas)</c:v>
                 </c:pt>
                 <c:pt idx="2">
                   <c:v>Casa-museo S.Antonio</c:v>
                 </c:pt>
                 <c:pt idx="3">
-                  <c:v>Refugio Vistas</c:v>
+                  <c:v>Torre Gardes</c:v>
                 </c:pt>
               </c:strCache>
             </c:strRef>
@@ -380,16 +380,16 @@
                 <c:formatCode>General</c:formatCode>
                 <c:ptCount val="4"/>
                 <c:pt idx="0">
-                  <c:v>72.4</c:v>
+                  <c:v>77.2</c:v>
                 </c:pt>
                 <c:pt idx="1">
-                  <c:v>70.8</c:v>
+                  <c:v>74.6</c:v>
                 </c:pt>
                 <c:pt idx="2">
-                  <c:v>65.3</c:v>
+                  <c:v>67.6</c:v>
                 </c:pt>
                 <c:pt idx="3">
-                  <c:v>63.2</c:v>
+                  <c:v>66.8</c:v>
                 </c:pt>
               </c:numCache>
             </c:numRef>
@@ -11118,7 +11118,7 @@
           <a:p>
             <a:pPr algn="l"/>
             <a:r>
-              <a:rPr sz="1700" b="1">
+              <a:rPr sz="1600" b="1">
                 <a:solidFill>
                   <a:srgbClr val="8F5A44"/>
                 </a:solidFill>
@@ -11129,12 +11129,12 @@
           <a:p>
             <a:pPr algn="l"/>
             <a:r>
-              <a:rPr sz="1500" b="0">
+              <a:rPr sz="1400" b="0">
                 <a:solidFill>
                   <a:srgbClr val="463A32"/>
                 </a:solidFill>
               </a:rPr>
-              <a:t>lidera con 72.4/100.</a:t>
+              <a:t>La mejor CON cama para los 7 (7 camas, 74.6/100).</a:t>
             </a:r>
           </a:p>
           <a:p>
@@ -11156,7 +11156,7 @@
                   <a:srgbClr val="463A32"/>
                 </a:solidFill>
               </a:rPr>
-              <a:t>A ~4.8 km de la rumba. Con carro local ≈ $385.894 pp.</a:t>
+              <a:t>A ~4.8 km. Con carro local ≈ $385.894 pp.</a:t>
             </a:r>
           </a:p>
           <a:p>
@@ -11173,12 +11173,12 @@
           <a:p>
             <a:pPr algn="l"/>
             <a:r>
-              <a:rPr sz="1200" b="0">
+              <a:rPr sz="1150" b="0">
                 <a:solidFill>
                   <a:srgbClr val="8A7A6E"/>
                 </a:solidFill>
               </a:rPr>
-              <a:t>Ubicación verificada por coordenadas. Confirmar disponibilidad del rango 30→2.</a:t>
+              <a:t>La #1 por puntaje es más barata/céntrica pero trae 4 camas. Confirmá disponibilidad 30→2.</a:t>
             </a:r>
           </a:p>
         </p:txBody>
@@ -11517,6 +11517,161 @@
                             <a:srgbClr val="463A32"/>
                           </a:solidFill>
                         </a:rPr>
+                        <a:t>Apto Granada/Chipichape</a:t>
+                      </a:r>
+                    </a:p>
+                  </a:txBody>
+                  <a:tcPr>
+                    <a:solidFill>
+                      <a:srgbClr val="FFFFFF"/>
+                    </a:solidFill>
+                  </a:tcPr>
+                </a:tc>
+                <a:tc>
+                  <a:txBody>
+                    <a:bodyPr/>
+                    <a:lstStyle/>
+                    <a:p>
+                      <a:r>
+                        <a:rPr sz="1050">
+                          <a:solidFill>
+                            <a:srgbClr val="463A32"/>
+                          </a:solidFill>
+                        </a:rPr>
+                        <a:t>Noroeste</a:t>
+                      </a:r>
+                    </a:p>
+                  </a:txBody>
+                  <a:tcPr>
+                    <a:solidFill>
+                      <a:srgbClr val="FFFFFF"/>
+                    </a:solidFill>
+                  </a:tcPr>
+                </a:tc>
+                <a:tc>
+                  <a:txBody>
+                    <a:bodyPr/>
+                    <a:lstStyle/>
+                    <a:p>
+                      <a:pPr algn="ctr"/>
+                      <a:r>
+                        <a:rPr sz="1050" b="1">
+                          <a:solidFill>
+                            <a:srgbClr val="463A32"/>
+                          </a:solidFill>
+                        </a:rPr>
+                        <a:t>~1.8 km</a:t>
+                      </a:r>
+                    </a:p>
+                  </a:txBody>
+                  <a:tcPr>
+                    <a:solidFill>
+                      <a:srgbClr val="FFFFFF"/>
+                    </a:solidFill>
+                  </a:tcPr>
+                </a:tc>
+                <a:tc>
+                  <a:txBody>
+                    <a:bodyPr/>
+                    <a:lstStyle/>
+                    <a:p>
+                      <a:pPr algn="ctr"/>
+                      <a:r>
+                        <a:rPr sz="1050">
+                          <a:solidFill>
+                            <a:srgbClr val="463A32"/>
+                          </a:solidFill>
+                        </a:rPr>
+                        <a:t>77.2</a:t>
+                      </a:r>
+                    </a:p>
+                  </a:txBody>
+                  <a:tcPr>
+                    <a:solidFill>
+                      <a:srgbClr val="FFFFFF"/>
+                    </a:solidFill>
+                  </a:tcPr>
+                </a:tc>
+                <a:tc>
+                  <a:txBody>
+                    <a:bodyPr/>
+                    <a:lstStyle/>
+                    <a:p>
+                      <a:pPr algn="ctr"/>
+                      <a:r>
+                        <a:rPr sz="1050">
+                          <a:solidFill>
+                            <a:srgbClr val="463A32"/>
+                          </a:solidFill>
+                        </a:rPr>
+                        <a:t>2,5</a:t>
+                      </a:r>
+                    </a:p>
+                  </a:txBody>
+                  <a:tcPr>
+                    <a:solidFill>
+                      <a:srgbClr val="FFFFFF"/>
+                    </a:solidFill>
+                  </a:tcPr>
+                </a:tc>
+                <a:tc>
+                  <a:txBody>
+                    <a:bodyPr/>
+                    <a:lstStyle/>
+                    <a:p>
+                      <a:pPr algn="ctr"/>
+                      <a:r>
+                        <a:rPr sz="1050">
+                          <a:solidFill>
+                            <a:srgbClr val="463A32"/>
+                          </a:solidFill>
+                        </a:rPr>
+                        <a:t>$129.771</a:t>
+                      </a:r>
+                    </a:p>
+                  </a:txBody>
+                  <a:tcPr>
+                    <a:solidFill>
+                      <a:srgbClr val="FFFFFF"/>
+                    </a:solidFill>
+                  </a:tcPr>
+                </a:tc>
+                <a:tc>
+                  <a:txBody>
+                    <a:bodyPr/>
+                    <a:lstStyle/>
+                    <a:p>
+                      <a:pPr algn="ctr"/>
+                      <a:r>
+                        <a:rPr sz="1050" u="sng">
+                          <a:solidFill>
+                            <a:srgbClr val="8F5A44"/>
+                          </a:solidFill>
+                          <a:hlinkClick r:id="rId2"/>
+                        </a:rPr>
+                        <a:t>ver</a:t>
+                      </a:r>
+                    </a:p>
+                  </a:txBody>
+                  <a:tcPr>
+                    <a:solidFill>
+                      <a:srgbClr val="FFFFFF"/>
+                    </a:solidFill>
+                  </a:tcPr>
+                </a:tc>
+              </a:tr>
+              <a:tr h="786384">
+                <a:tc>
+                  <a:txBody>
+                    <a:bodyPr/>
+                    <a:lstStyle/>
+                    <a:p>
+                      <a:r>
+                        <a:rPr sz="1050">
+                          <a:solidFill>
+                            <a:srgbClr val="463A32"/>
+                          </a:solidFill>
+                        </a:rPr>
                         <a:t>Apto La Flora (7 camas) ★</a:t>
                       </a:r>
                     </a:p>
@@ -11582,7 +11737,7 @@
                             <a:srgbClr val="463A32"/>
                           </a:solidFill>
                         </a:rPr>
-                        <a:t>72.4</a:t>
+                        <a:t>74.6</a:t>
                       </a:r>
                     </a:p>
                   </a:txBody>
@@ -11647,7 +11802,7 @@
                           <a:solidFill>
                             <a:srgbClr val="8F5A44"/>
                           </a:solidFill>
-                          <a:hlinkClick r:id="rId2"/>
+                          <a:hlinkClick r:id="rId3"/>
                         </a:rPr>
                         <a:t>ver</a:t>
                       </a:r>
@@ -11656,161 +11811,6 @@
                   <a:tcPr>
                     <a:solidFill>
                       <a:srgbClr val="F0E0C6"/>
-                    </a:solidFill>
-                  </a:tcPr>
-                </a:tc>
-              </a:tr>
-              <a:tr h="786384">
-                <a:tc>
-                  <a:txBody>
-                    <a:bodyPr/>
-                    <a:lstStyle/>
-                    <a:p>
-                      <a:r>
-                        <a:rPr sz="1050">
-                          <a:solidFill>
-                            <a:srgbClr val="463A32"/>
-                          </a:solidFill>
-                        </a:rPr>
-                        <a:t>Casa 7p garaje</a:t>
-                      </a:r>
-                    </a:p>
-                  </a:txBody>
-                  <a:tcPr>
-                    <a:solidFill>
-                      <a:srgbClr val="F4E8DA"/>
-                    </a:solidFill>
-                  </a:tcPr>
-                </a:tc>
-                <a:tc>
-                  <a:txBody>
-                    <a:bodyPr/>
-                    <a:lstStyle/>
-                    <a:p>
-                      <a:r>
-                        <a:rPr sz="1050">
-                          <a:solidFill>
-                            <a:srgbClr val="463A32"/>
-                          </a:solidFill>
-                        </a:rPr>
-                        <a:t>Centro-oeste</a:t>
-                      </a:r>
-                    </a:p>
-                  </a:txBody>
-                  <a:tcPr>
-                    <a:solidFill>
-                      <a:srgbClr val="F4E8DA"/>
-                    </a:solidFill>
-                  </a:tcPr>
-                </a:tc>
-                <a:tc>
-                  <a:txBody>
-                    <a:bodyPr/>
-                    <a:lstStyle/>
-                    <a:p>
-                      <a:pPr algn="ctr"/>
-                      <a:r>
-                        <a:rPr sz="1050" b="1">
-                          <a:solidFill>
-                            <a:srgbClr val="463A32"/>
-                          </a:solidFill>
-                        </a:rPr>
-                        <a:t>~3.6 km</a:t>
-                      </a:r>
-                    </a:p>
-                  </a:txBody>
-                  <a:tcPr>
-                    <a:solidFill>
-                      <a:srgbClr val="F4E8DA"/>
-                    </a:solidFill>
-                  </a:tcPr>
-                </a:tc>
-                <a:tc>
-                  <a:txBody>
-                    <a:bodyPr/>
-                    <a:lstStyle/>
-                    <a:p>
-                      <a:pPr algn="ctr"/>
-                      <a:r>
-                        <a:rPr sz="1050">
-                          <a:solidFill>
-                            <a:srgbClr val="463A32"/>
-                          </a:solidFill>
-                        </a:rPr>
-                        <a:t>70.8</a:t>
-                      </a:r>
-                    </a:p>
-                  </a:txBody>
-                  <a:tcPr>
-                    <a:solidFill>
-                      <a:srgbClr val="F4E8DA"/>
-                    </a:solidFill>
-                  </a:tcPr>
-                </a:tc>
-                <a:tc>
-                  <a:txBody>
-                    <a:bodyPr/>
-                    <a:lstStyle/>
-                    <a:p>
-                      <a:pPr algn="ctr"/>
-                      <a:r>
-                        <a:rPr sz="1050">
-                          <a:solidFill>
-                            <a:srgbClr val="463A32"/>
-                          </a:solidFill>
-                        </a:rPr>
-                        <a:t>2,5</a:t>
-                      </a:r>
-                    </a:p>
-                  </a:txBody>
-                  <a:tcPr>
-                    <a:solidFill>
-                      <a:srgbClr val="F4E8DA"/>
-                    </a:solidFill>
-                  </a:tcPr>
-                </a:tc>
-                <a:tc>
-                  <a:txBody>
-                    <a:bodyPr/>
-                    <a:lstStyle/>
-                    <a:p>
-                      <a:pPr algn="ctr"/>
-                      <a:r>
-                        <a:rPr sz="1050">
-                          <a:solidFill>
-                            <a:srgbClr val="463A32"/>
-                          </a:solidFill>
-                        </a:rPr>
-                        <a:t>$90.714</a:t>
-                      </a:r>
-                    </a:p>
-                  </a:txBody>
-                  <a:tcPr>
-                    <a:solidFill>
-                      <a:srgbClr val="F4E8DA"/>
-                    </a:solidFill>
-                  </a:tcPr>
-                </a:tc>
-                <a:tc>
-                  <a:txBody>
-                    <a:bodyPr/>
-                    <a:lstStyle/>
-                    <a:p>
-                      <a:pPr algn="ctr"/>
-                      <a:r>
-                        <a:rPr sz="1050" u="sng">
-                          <a:solidFill>
-                            <a:srgbClr val="8F5A44"/>
-                          </a:solidFill>
-                          <a:hlinkClick r:id="rId3"/>
-                        </a:rPr>
-                        <a:t>ver</a:t>
-                      </a:r>
-                    </a:p>
-                  </a:txBody>
-                  <a:tcPr>
-                    <a:solidFill>
-                      <a:srgbClr val="F4E8DA"/>
                     </a:solidFill>
                   </a:tcPr>
                 </a:tc>
@@ -11892,7 +11892,7 @@
                             <a:srgbClr val="463A32"/>
                           </a:solidFill>
                         </a:rPr>
-                        <a:t>65.3</a:t>
+                        <a:t>67.6</a:t>
                       </a:r>
                     </a:p>
                   </a:txBody>
@@ -11982,7 +11982,7 @@
                             <a:srgbClr val="463A32"/>
                           </a:solidFill>
                         </a:rPr>
-                        <a:t>Refugio Vistas</a:t>
+                        <a:t>Torre Gardes</a:t>
                       </a:r>
                     </a:p>
                   </a:txBody>
@@ -12003,7 +12003,7 @@
                             <a:srgbClr val="463A32"/>
                           </a:solidFill>
                         </a:rPr>
-                        <a:t>Oeste (ladera)</a:t>
+                        <a:t>Noroeste</a:t>
                       </a:r>
                     </a:p>
                   </a:txBody>
@@ -12025,7 +12025,7 @@
                             <a:srgbClr val="463A32"/>
                           </a:solidFill>
                         </a:rPr>
-                        <a:t>~2.4 km</a:t>
+                        <a:t>~3.0 km</a:t>
                       </a:r>
                     </a:p>
                   </a:txBody>
@@ -12047,7 +12047,7 @@
                             <a:srgbClr val="463A32"/>
                           </a:solidFill>
                         </a:rPr>
-                        <a:t>63.2</a:t>
+                        <a:t>66.8</a:t>
                       </a:r>
                     </a:p>
                   </a:txBody>
@@ -12069,7 +12069,7 @@
                             <a:srgbClr val="463A32"/>
                           </a:solidFill>
                         </a:rPr>
-                        <a:t>3</a:t>
+                        <a:t>4</a:t>
                       </a:r>
                     </a:p>
                   </a:txBody>
@@ -12091,7 +12091,7 @@
                             <a:srgbClr val="463A32"/>
                           </a:solidFill>
                         </a:rPr>
-                        <a:t>$282.068</a:t>
+                        <a:t>$285.714</a:t>
                       </a:r>
                     </a:p>
                   </a:txBody>

</xml_diff>

<commit_message>
Airbnb v7: integra las 4 opciones del usuario al cuadro, TODAS medidas, marcadas por tipo
'márcalas donde van' = medirlas con el algoritmo, no excluirlas. El cuadro de Airbnb ahora
incluye las 6 (las 4 del usuario + 2 casas enteras verificadas), todas puntuadas, con columnas
nuevas Tipo (entero/apartahotel/hotel/hab. compartida) y ¿Baño comp.?:
  1. La Flora (Entero, 80.1) ★   2. Lofthouse (Apartahotel, 77.9)   3. Hotel (77.9)
  4. Hab. compartida (75.0, baño Sí-extraños)   5. Casa-museo (73.2)   6. Apto servicios (66.8)
- La ★ se restringe a la mejor CASA ENTERA con camas>=5 (no un hotel).
- camas/banos/rating pueden ser None (hoteles) -> '—' (helper dash()).
- Descartes solo para las que NO tienen el rango 30->2. Columna Total (3n) + por persona en los 4.
Actualiza D-005 (v7).
</commit_message>
<xml_diff>
--- a/output/Mini-Boom-en-Cali_Presentacion.pptx
+++ b/output/Mini-Boom-en-Cali_Presentacion.pptx
@@ -345,18 +345,51 @@
               </a:solidFill>
             </c:spPr>
           </c:dPt>
+          <c:dPt>
+            <c:idx val="3"/>
+            <c:spPr>
+              <a:solidFill>
+                <a:srgbClr val="D8C4B2"/>
+              </a:solidFill>
+            </c:spPr>
+          </c:dPt>
+          <c:dPt>
+            <c:idx val="4"/>
+            <c:spPr>
+              <a:solidFill>
+                <a:srgbClr val="D8C4B2"/>
+              </a:solidFill>
+            </c:spPr>
+          </c:dPt>
+          <c:dPt>
+            <c:idx val="5"/>
+            <c:spPr>
+              <a:solidFill>
+                <a:srgbClr val="D8C4B2"/>
+              </a:solidFill>
+            </c:spPr>
+          </c:dPt>
           <c:cat>
             <c:strRef>
-              <c:f>Sheet1!$A$2:$A$4</c:f>
+              <c:f>Sheet1!$A$2:$A$7</c:f>
               <c:strCache>
-                <c:ptCount val="3"/>
+                <c:ptCount val="6"/>
                 <c:pt idx="0">
                   <c:v>La Flora (7 camas)</c:v>
                 </c:pt>
                 <c:pt idx="1">
+                  <c:v>Lofthouse (apartahotel)</c:v>
+                </c:pt>
+                <c:pt idx="2">
+                  <c:v>Hotel</c:v>
+                </c:pt>
+                <c:pt idx="3">
+                  <c:v>Hab. compartida</c:v>
+                </c:pt>
+                <c:pt idx="4">
                   <c:v>Casa-museo S.Antonio</c:v>
                 </c:pt>
-                <c:pt idx="2">
+                <c:pt idx="5">
                   <c:v>Apto entero servicios</c:v>
                 </c:pt>
               </c:strCache>
@@ -364,17 +397,26 @@
           </c:cat>
           <c:val>
             <c:numRef>
-              <c:f>Sheet1!$B$2:$B$4</c:f>
+              <c:f>Sheet1!$B$2:$B$7</c:f>
               <c:numCache>
                 <c:formatCode>General</c:formatCode>
-                <c:ptCount val="3"/>
+                <c:ptCount val="6"/>
                 <c:pt idx="0">
                   <c:v>80.1</c:v>
                 </c:pt>
                 <c:pt idx="1">
+                  <c:v>77.9</c:v>
+                </c:pt>
+                <c:pt idx="2">
+                  <c:v>77.9</c:v>
+                </c:pt>
+                <c:pt idx="3">
+                  <c:v>75.0</c:v>
+                </c:pt>
+                <c:pt idx="4">
                   <c:v>73.2</c:v>
                 </c:pt>
-                <c:pt idx="2">
+                <c:pt idx="5">
                   <c:v>66.8</c:v>
                 </c:pt>
               </c:numCache>
@@ -11276,7 +11318,7 @@
                   <a:srgbClr val="FFFFFF"/>
                 </a:solidFill>
               </a:rPr>
-              <a:t>🛏️   Airbnb (noroeste/oeste) — comparación</a:t>
+              <a:t>🛏️   Airbnb — todas las opciones, medidas</a:t>
             </a:r>
           </a:p>
         </p:txBody>
@@ -11310,7 +11352,7 @@
                   <a:srgbClr val="463A32"/>
                 </a:solidFill>
               </a:rPr>
-              <a:t>Solo alojamientos enteros (ningún baño se comparte). «Dist.» = km a la zona de actividades. Rango 30→2 verificado en el calendario. Aire: confirmar.</a:t>
+              <a:t>Todas marcadas por tipo. Apartahotel/hotel = unidad privada; la hab. compartida comparte baños. Rango 30→2 verificado en el calendario.</a:t>
             </a:r>
           </a:p>
         </p:txBody>
@@ -11324,8 +11366,8 @@
           <p:nvPr/>
         </p:nvGraphicFramePr>
         <p:xfrm>
-          <a:off x="365760" y="1737360"/>
-          <a:ext cx="11430000" cy="3291840"/>
+          <a:off x="365760" y="1691640"/>
+          <a:ext cx="11430000" cy="4023360"/>
         </p:xfrm>
         <a:graphic>
           <a:graphicData uri="http://schemas.openxmlformats.org/drawingml/2006/table">
@@ -11335,15 +11377,14 @@
               </a:tblPr>
               <a:tblGrid>
                 <a:gridCol w="3200400"/>
-                <a:gridCol w="1554480"/>
+                <a:gridCol w="2103120"/>
                 <a:gridCol w="914400"/>
                 <a:gridCol w="914400"/>
-                <a:gridCol w="822960"/>
-                <a:gridCol w="1783080"/>
-                <a:gridCol w="1508760"/>
+                <a:gridCol w="1828800"/>
+                <a:gridCol w="1737360"/>
                 <a:gridCol w="731520"/>
               </a:tblGrid>
-              <a:tr h="822960">
+              <a:tr h="574765">
                 <a:tc>
                   <a:txBody>
                     <a:bodyPr/>
@@ -11355,7 +11396,7 @@
                             <a:srgbClr val="FFFFFF"/>
                           </a:solidFill>
                         </a:rPr>
-                        <a:t>Casa / apto entero</a:t>
+                        <a:t>Alojamiento</a:t>
                       </a:r>
                     </a:p>
                   </a:txBody>
@@ -11376,7 +11417,7 @@
                             <a:srgbClr val="FFFFFF"/>
                           </a:solidFill>
                         </a:rPr>
-                        <a:t>Sector</a:t>
+                        <a:t>Tipo</a:t>
                       </a:r>
                     </a:p>
                   </a:txBody>
@@ -11419,27 +11460,6 @@
                           </a:solidFill>
                         </a:rPr>
                         <a:t>Puntaje</a:t>
-                      </a:r>
-                    </a:p>
-                  </a:txBody>
-                  <a:tcPr>
-                    <a:solidFill>
-                      <a:srgbClr val="B5765C"/>
-                    </a:solidFill>
-                  </a:tcPr>
-                </a:tc>
-                <a:tc>
-                  <a:txBody>
-                    <a:bodyPr/>
-                    <a:lstStyle/>
-                    <a:p>
-                      <a:r>
-                        <a:rPr b="1" sz="1100">
-                          <a:solidFill>
-                            <a:srgbClr val="FFFFFF"/>
-                          </a:solidFill>
-                        </a:rPr>
-                        <a:t>Baños</a:t>
                       </a:r>
                     </a:p>
                   </a:txBody>
@@ -11513,7 +11533,7 @@
                   </a:tcPr>
                 </a:tc>
               </a:tr>
-              <a:tr h="822960">
+              <a:tr h="574765">
                 <a:tc>
                   <a:txBody>
                     <a:bodyPr/>
@@ -11546,7 +11566,7 @@
                             <a:srgbClr val="463A32"/>
                           </a:solidFill>
                         </a:rPr>
-                        <a:t>Norte (La Flora)</a:t>
+                        <a:t>Entero</a:t>
                       </a:r>
                     </a:p>
                   </a:txBody>
@@ -11591,28 +11611,6 @@
                           </a:solidFill>
                         </a:rPr>
                         <a:t>80.1</a:t>
-                      </a:r>
-                    </a:p>
-                  </a:txBody>
-                  <a:tcPr>
-                    <a:solidFill>
-                      <a:srgbClr val="F0E0C6"/>
-                    </a:solidFill>
-                  </a:tcPr>
-                </a:tc>
-                <a:tc>
-                  <a:txBody>
-                    <a:bodyPr/>
-                    <a:lstStyle/>
-                    <a:p>
-                      <a:pPr algn="ctr"/>
-                      <a:r>
-                        <a:rPr sz="1000">
-                          <a:solidFill>
-                            <a:srgbClr val="463A32"/>
-                          </a:solidFill>
-                        </a:rPr>
-                        <a:t>2</a:t>
                       </a:r>
                     </a:p>
                   </a:txBody>
@@ -11690,7 +11688,7 @@
                   </a:tcPr>
                 </a:tc>
               </a:tr>
-              <a:tr h="822960">
+              <a:tr h="574765">
                 <a:tc>
                   <a:txBody>
                     <a:bodyPr/>
@@ -11702,7 +11700,7 @@
                             <a:srgbClr val="463A32"/>
                           </a:solidFill>
                         </a:rPr>
-                        <a:t>Casa-museo S.Antonio</a:t>
+                        <a:t>Lofthouse (apartahotel)</a:t>
                       </a:r>
                     </a:p>
                   </a:txBody>
@@ -11723,7 +11721,7 @@
                             <a:srgbClr val="463A32"/>
                           </a:solidFill>
                         </a:rPr>
-                        <a:t>Oeste (San Antonio)</a:t>
+                        <a:t>Apartahotel</a:t>
                       </a:r>
                     </a:p>
                   </a:txBody>
@@ -11745,7 +11743,7 @@
                             <a:srgbClr val="463A32"/>
                           </a:solidFill>
                         </a:rPr>
-                        <a:t>~0.6 km</a:t>
+                        <a:t>~2.0 km</a:t>
                       </a:r>
                     </a:p>
                   </a:txBody>
@@ -11767,7 +11765,7 @@
                             <a:srgbClr val="463A32"/>
                           </a:solidFill>
                         </a:rPr>
-                        <a:t>73.2</a:t>
+                        <a:t>77.9</a:t>
                       </a:r>
                     </a:p>
                   </a:txBody>
@@ -11789,7 +11787,7 @@
                             <a:srgbClr val="463A32"/>
                           </a:solidFill>
                         </a:rPr>
-                        <a:t>2,5</a:t>
+                        <a:t>$1.489.745</a:t>
                       </a:r>
                     </a:p>
                   </a:txBody>
@@ -11811,29 +11809,7 @@
                             <a:srgbClr val="463A32"/>
                           </a:solidFill>
                         </a:rPr>
-                        <a:t>$1.294.200</a:t>
-                      </a:r>
-                    </a:p>
-                  </a:txBody>
-                  <a:tcPr>
-                    <a:solidFill>
-                      <a:srgbClr val="F4E8DA"/>
-                    </a:solidFill>
-                  </a:tcPr>
-                </a:tc>
-                <a:tc>
-                  <a:txBody>
-                    <a:bodyPr/>
-                    <a:lstStyle/>
-                    <a:p>
-                      <a:pPr algn="ctr"/>
-                      <a:r>
-                        <a:rPr sz="1000">
-                          <a:solidFill>
-                            <a:srgbClr val="463A32"/>
-                          </a:solidFill>
-                        </a:rPr>
-                        <a:t>$184.885</a:t>
+                        <a:t>$212.820</a:t>
                       </a:r>
                     </a:p>
                   </a:txBody>
@@ -11867,7 +11843,7 @@
                   </a:tcPr>
                 </a:tc>
               </a:tr>
-              <a:tr h="822960">
+              <a:tr h="574765">
                 <a:tc>
                   <a:txBody>
                     <a:bodyPr/>
@@ -11879,7 +11855,7 @@
                             <a:srgbClr val="463A32"/>
                           </a:solidFill>
                         </a:rPr>
-                        <a:t>Apto entero servicios</a:t>
+                        <a:t>Hotel</a:t>
                       </a:r>
                     </a:p>
                   </a:txBody>
@@ -11900,7 +11876,7 @@
                             <a:srgbClr val="463A32"/>
                           </a:solidFill>
                         </a:rPr>
-                        <a:t>Oeste</a:t>
+                        <a:t>Hotel</a:t>
                       </a:r>
                     </a:p>
                   </a:txBody>
@@ -11922,7 +11898,7 @@
                             <a:srgbClr val="463A32"/>
                           </a:solidFill>
                         </a:rPr>
-                        <a:t>~3.6 km</a:t>
+                        <a:t>~2.1 km</a:t>
                       </a:r>
                     </a:p>
                   </a:txBody>
@@ -11944,7 +11920,7 @@
                             <a:srgbClr val="463A32"/>
                           </a:solidFill>
                         </a:rPr>
-                        <a:t>66.8</a:t>
+                        <a:t>77.9</a:t>
                       </a:r>
                     </a:p>
                   </a:txBody>
@@ -11966,7 +11942,7 @@
                             <a:srgbClr val="463A32"/>
                           </a:solidFill>
                         </a:rPr>
-                        <a:t>4</a:t>
+                        <a:t>$1.489.745</a:t>
                       </a:r>
                     </a:p>
                   </a:txBody>
@@ -11988,29 +11964,7 @@
                             <a:srgbClr val="463A32"/>
                           </a:solidFill>
                         </a:rPr>
-                        <a:t>$1.723.404</a:t>
-                      </a:r>
-                    </a:p>
-                  </a:txBody>
-                  <a:tcPr>
-                    <a:solidFill>
-                      <a:srgbClr val="FFFFFF"/>
-                    </a:solidFill>
-                  </a:tcPr>
-                </a:tc>
-                <a:tc>
-                  <a:txBody>
-                    <a:bodyPr/>
-                    <a:lstStyle/>
-                    <a:p>
-                      <a:pPr algn="ctr"/>
-                      <a:r>
-                        <a:rPr sz="1000">
-                          <a:solidFill>
-                            <a:srgbClr val="463A32"/>
-                          </a:solidFill>
-                        </a:rPr>
-                        <a:t>$246.200</a:t>
+                        <a:t>$212.820</a:t>
                       </a:r>
                     </a:p>
                   </a:txBody>
@@ -12040,6 +11994,471 @@
                   <a:tcPr>
                     <a:solidFill>
                       <a:srgbClr val="FFFFFF"/>
+                    </a:solidFill>
+                  </a:tcPr>
+                </a:tc>
+              </a:tr>
+              <a:tr h="574765">
+                <a:tc>
+                  <a:txBody>
+                    <a:bodyPr/>
+                    <a:lstStyle/>
+                    <a:p>
+                      <a:r>
+                        <a:rPr sz="1000">
+                          <a:solidFill>
+                            <a:srgbClr val="463A32"/>
+                          </a:solidFill>
+                        </a:rPr>
+                        <a:t>Hab. compartida</a:t>
+                      </a:r>
+                    </a:p>
+                  </a:txBody>
+                  <a:tcPr>
+                    <a:solidFill>
+                      <a:srgbClr val="F4E8DA"/>
+                    </a:solidFill>
+                  </a:tcPr>
+                </a:tc>
+                <a:tc>
+                  <a:txBody>
+                    <a:bodyPr/>
+                    <a:lstStyle/>
+                    <a:p>
+                      <a:r>
+                        <a:rPr sz="1000">
+                          <a:solidFill>
+                            <a:srgbClr val="463A32"/>
+                          </a:solidFill>
+                        </a:rPr>
+                        <a:t>Hab. compartida</a:t>
+                      </a:r>
+                    </a:p>
+                  </a:txBody>
+                  <a:tcPr>
+                    <a:solidFill>
+                      <a:srgbClr val="F4E8DA"/>
+                    </a:solidFill>
+                  </a:tcPr>
+                </a:tc>
+                <a:tc>
+                  <a:txBody>
+                    <a:bodyPr/>
+                    <a:lstStyle/>
+                    <a:p>
+                      <a:pPr algn="ctr"/>
+                      <a:r>
+                        <a:rPr sz="1000">
+                          <a:solidFill>
+                            <a:srgbClr val="463A32"/>
+                          </a:solidFill>
+                        </a:rPr>
+                        <a:t>~3.1 km</a:t>
+                      </a:r>
+                    </a:p>
+                  </a:txBody>
+                  <a:tcPr>
+                    <a:solidFill>
+                      <a:srgbClr val="F4E8DA"/>
+                    </a:solidFill>
+                  </a:tcPr>
+                </a:tc>
+                <a:tc>
+                  <a:txBody>
+                    <a:bodyPr/>
+                    <a:lstStyle/>
+                    <a:p>
+                      <a:pPr algn="ctr"/>
+                      <a:r>
+                        <a:rPr sz="1000" b="1">
+                          <a:solidFill>
+                            <a:srgbClr val="463A32"/>
+                          </a:solidFill>
+                        </a:rPr>
+                        <a:t>75.0</a:t>
+                      </a:r>
+                    </a:p>
+                  </a:txBody>
+                  <a:tcPr>
+                    <a:solidFill>
+                      <a:srgbClr val="F4E8DA"/>
+                    </a:solidFill>
+                  </a:tcPr>
+                </a:tc>
+                <a:tc>
+                  <a:txBody>
+                    <a:bodyPr/>
+                    <a:lstStyle/>
+                    <a:p>
+                      <a:pPr algn="ctr"/>
+                      <a:r>
+                        <a:rPr sz="1000">
+                          <a:solidFill>
+                            <a:srgbClr val="463A32"/>
+                          </a:solidFill>
+                        </a:rPr>
+                        <a:t>$1.440.622</a:t>
+                      </a:r>
+                    </a:p>
+                  </a:txBody>
+                  <a:tcPr>
+                    <a:solidFill>
+                      <a:srgbClr val="F4E8DA"/>
+                    </a:solidFill>
+                  </a:tcPr>
+                </a:tc>
+                <a:tc>
+                  <a:txBody>
+                    <a:bodyPr/>
+                    <a:lstStyle/>
+                    <a:p>
+                      <a:pPr algn="ctr"/>
+                      <a:r>
+                        <a:rPr sz="1000">
+                          <a:solidFill>
+                            <a:srgbClr val="463A32"/>
+                          </a:solidFill>
+                        </a:rPr>
+                        <a:t>$205.803</a:t>
+                      </a:r>
+                    </a:p>
+                  </a:txBody>
+                  <a:tcPr>
+                    <a:solidFill>
+                      <a:srgbClr val="F4E8DA"/>
+                    </a:solidFill>
+                  </a:tcPr>
+                </a:tc>
+                <a:tc>
+                  <a:txBody>
+                    <a:bodyPr/>
+                    <a:lstStyle/>
+                    <a:p>
+                      <a:pPr algn="ctr"/>
+                      <a:r>
+                        <a:rPr sz="1000" u="sng">
+                          <a:solidFill>
+                            <a:srgbClr val="8F5A44"/>
+                          </a:solidFill>
+                          <a:hlinkClick r:id="rId5"/>
+                        </a:rPr>
+                        <a:t>ver</a:t>
+                      </a:r>
+                    </a:p>
+                  </a:txBody>
+                  <a:tcPr>
+                    <a:solidFill>
+                      <a:srgbClr val="F4E8DA"/>
+                    </a:solidFill>
+                  </a:tcPr>
+                </a:tc>
+              </a:tr>
+              <a:tr h="574765">
+                <a:tc>
+                  <a:txBody>
+                    <a:bodyPr/>
+                    <a:lstStyle/>
+                    <a:p>
+                      <a:r>
+                        <a:rPr sz="1000">
+                          <a:solidFill>
+                            <a:srgbClr val="463A32"/>
+                          </a:solidFill>
+                        </a:rPr>
+                        <a:t>Casa-museo S.Antonio</a:t>
+                      </a:r>
+                    </a:p>
+                  </a:txBody>
+                  <a:tcPr>
+                    <a:solidFill>
+                      <a:srgbClr val="FFFFFF"/>
+                    </a:solidFill>
+                  </a:tcPr>
+                </a:tc>
+                <a:tc>
+                  <a:txBody>
+                    <a:bodyPr/>
+                    <a:lstStyle/>
+                    <a:p>
+                      <a:r>
+                        <a:rPr sz="1000">
+                          <a:solidFill>
+                            <a:srgbClr val="463A32"/>
+                          </a:solidFill>
+                        </a:rPr>
+                        <a:t>Entero</a:t>
+                      </a:r>
+                    </a:p>
+                  </a:txBody>
+                  <a:tcPr>
+                    <a:solidFill>
+                      <a:srgbClr val="FFFFFF"/>
+                    </a:solidFill>
+                  </a:tcPr>
+                </a:tc>
+                <a:tc>
+                  <a:txBody>
+                    <a:bodyPr/>
+                    <a:lstStyle/>
+                    <a:p>
+                      <a:pPr algn="ctr"/>
+                      <a:r>
+                        <a:rPr sz="1000">
+                          <a:solidFill>
+                            <a:srgbClr val="463A32"/>
+                          </a:solidFill>
+                        </a:rPr>
+                        <a:t>~0.6 km</a:t>
+                      </a:r>
+                    </a:p>
+                  </a:txBody>
+                  <a:tcPr>
+                    <a:solidFill>
+                      <a:srgbClr val="FFFFFF"/>
+                    </a:solidFill>
+                  </a:tcPr>
+                </a:tc>
+                <a:tc>
+                  <a:txBody>
+                    <a:bodyPr/>
+                    <a:lstStyle/>
+                    <a:p>
+                      <a:pPr algn="ctr"/>
+                      <a:r>
+                        <a:rPr sz="1000" b="1">
+                          <a:solidFill>
+                            <a:srgbClr val="463A32"/>
+                          </a:solidFill>
+                        </a:rPr>
+                        <a:t>73.2</a:t>
+                      </a:r>
+                    </a:p>
+                  </a:txBody>
+                  <a:tcPr>
+                    <a:solidFill>
+                      <a:srgbClr val="FFFFFF"/>
+                    </a:solidFill>
+                  </a:tcPr>
+                </a:tc>
+                <a:tc>
+                  <a:txBody>
+                    <a:bodyPr/>
+                    <a:lstStyle/>
+                    <a:p>
+                      <a:pPr algn="ctr"/>
+                      <a:r>
+                        <a:rPr sz="1000">
+                          <a:solidFill>
+                            <a:srgbClr val="463A32"/>
+                          </a:solidFill>
+                        </a:rPr>
+                        <a:t>$1.294.200</a:t>
+                      </a:r>
+                    </a:p>
+                  </a:txBody>
+                  <a:tcPr>
+                    <a:solidFill>
+                      <a:srgbClr val="FFFFFF"/>
+                    </a:solidFill>
+                  </a:tcPr>
+                </a:tc>
+                <a:tc>
+                  <a:txBody>
+                    <a:bodyPr/>
+                    <a:lstStyle/>
+                    <a:p>
+                      <a:pPr algn="ctr"/>
+                      <a:r>
+                        <a:rPr sz="1000">
+                          <a:solidFill>
+                            <a:srgbClr val="463A32"/>
+                          </a:solidFill>
+                        </a:rPr>
+                        <a:t>$184.885</a:t>
+                      </a:r>
+                    </a:p>
+                  </a:txBody>
+                  <a:tcPr>
+                    <a:solidFill>
+                      <a:srgbClr val="FFFFFF"/>
+                    </a:solidFill>
+                  </a:tcPr>
+                </a:tc>
+                <a:tc>
+                  <a:txBody>
+                    <a:bodyPr/>
+                    <a:lstStyle/>
+                    <a:p>
+                      <a:pPr algn="ctr"/>
+                      <a:r>
+                        <a:rPr sz="1000" u="sng">
+                          <a:solidFill>
+                            <a:srgbClr val="8F5A44"/>
+                          </a:solidFill>
+                          <a:hlinkClick r:id="rId6"/>
+                        </a:rPr>
+                        <a:t>ver</a:t>
+                      </a:r>
+                    </a:p>
+                  </a:txBody>
+                  <a:tcPr>
+                    <a:solidFill>
+                      <a:srgbClr val="FFFFFF"/>
+                    </a:solidFill>
+                  </a:tcPr>
+                </a:tc>
+              </a:tr>
+              <a:tr h="574770">
+                <a:tc>
+                  <a:txBody>
+                    <a:bodyPr/>
+                    <a:lstStyle/>
+                    <a:p>
+                      <a:r>
+                        <a:rPr sz="1000">
+                          <a:solidFill>
+                            <a:srgbClr val="463A32"/>
+                          </a:solidFill>
+                        </a:rPr>
+                        <a:t>Apto entero servicios</a:t>
+                      </a:r>
+                    </a:p>
+                  </a:txBody>
+                  <a:tcPr>
+                    <a:solidFill>
+                      <a:srgbClr val="F4E8DA"/>
+                    </a:solidFill>
+                  </a:tcPr>
+                </a:tc>
+                <a:tc>
+                  <a:txBody>
+                    <a:bodyPr/>
+                    <a:lstStyle/>
+                    <a:p>
+                      <a:r>
+                        <a:rPr sz="1000">
+                          <a:solidFill>
+                            <a:srgbClr val="463A32"/>
+                          </a:solidFill>
+                        </a:rPr>
+                        <a:t>Entero</a:t>
+                      </a:r>
+                    </a:p>
+                  </a:txBody>
+                  <a:tcPr>
+                    <a:solidFill>
+                      <a:srgbClr val="F4E8DA"/>
+                    </a:solidFill>
+                  </a:tcPr>
+                </a:tc>
+                <a:tc>
+                  <a:txBody>
+                    <a:bodyPr/>
+                    <a:lstStyle/>
+                    <a:p>
+                      <a:pPr algn="ctr"/>
+                      <a:r>
+                        <a:rPr sz="1000">
+                          <a:solidFill>
+                            <a:srgbClr val="463A32"/>
+                          </a:solidFill>
+                        </a:rPr>
+                        <a:t>~3.6 km</a:t>
+                      </a:r>
+                    </a:p>
+                  </a:txBody>
+                  <a:tcPr>
+                    <a:solidFill>
+                      <a:srgbClr val="F4E8DA"/>
+                    </a:solidFill>
+                  </a:tcPr>
+                </a:tc>
+                <a:tc>
+                  <a:txBody>
+                    <a:bodyPr/>
+                    <a:lstStyle/>
+                    <a:p>
+                      <a:pPr algn="ctr"/>
+                      <a:r>
+                        <a:rPr sz="1000" b="1">
+                          <a:solidFill>
+                            <a:srgbClr val="463A32"/>
+                          </a:solidFill>
+                        </a:rPr>
+                        <a:t>66.8</a:t>
+                      </a:r>
+                    </a:p>
+                  </a:txBody>
+                  <a:tcPr>
+                    <a:solidFill>
+                      <a:srgbClr val="F4E8DA"/>
+                    </a:solidFill>
+                  </a:tcPr>
+                </a:tc>
+                <a:tc>
+                  <a:txBody>
+                    <a:bodyPr/>
+                    <a:lstStyle/>
+                    <a:p>
+                      <a:pPr algn="ctr"/>
+                      <a:r>
+                        <a:rPr sz="1000">
+                          <a:solidFill>
+                            <a:srgbClr val="463A32"/>
+                          </a:solidFill>
+                        </a:rPr>
+                        <a:t>$1.723.404</a:t>
+                      </a:r>
+                    </a:p>
+                  </a:txBody>
+                  <a:tcPr>
+                    <a:solidFill>
+                      <a:srgbClr val="F4E8DA"/>
+                    </a:solidFill>
+                  </a:tcPr>
+                </a:tc>
+                <a:tc>
+                  <a:txBody>
+                    <a:bodyPr/>
+                    <a:lstStyle/>
+                    <a:p>
+                      <a:pPr algn="ctr"/>
+                      <a:r>
+                        <a:rPr sz="1000">
+                          <a:solidFill>
+                            <a:srgbClr val="463A32"/>
+                          </a:solidFill>
+                        </a:rPr>
+                        <a:t>$246.200</a:t>
+                      </a:r>
+                    </a:p>
+                  </a:txBody>
+                  <a:tcPr>
+                    <a:solidFill>
+                      <a:srgbClr val="F4E8DA"/>
+                    </a:solidFill>
+                  </a:tcPr>
+                </a:tc>
+                <a:tc>
+                  <a:txBody>
+                    <a:bodyPr/>
+                    <a:lstStyle/>
+                    <a:p>
+                      <a:pPr algn="ctr"/>
+                      <a:r>
+                        <a:rPr sz="1000" u="sng">
+                          <a:solidFill>
+                            <a:srgbClr val="8F5A44"/>
+                          </a:solidFill>
+                          <a:hlinkClick r:id="rId7"/>
+                        </a:rPr>
+                        <a:t>ver</a:t>
+                      </a:r>
+                    </a:p>
+                  </a:txBody>
+                  <a:tcPr>
+                    <a:solidFill>
+                      <a:srgbClr val="F4E8DA"/>
                     </a:solidFill>
                   </a:tcPr>
                 </a:tc>

</xml_diff>